<commit_message>
Deck slide 14: measured AV1 result; results page gains the AV1 section
</commit_message>
<xml_diff>
--- a/slides/polar-codec.pptx
+++ b/slides/polar-codec.pptx
@@ -3229,7 +3229,7 @@
                 </a:solidFill>
                 <a:latin typeface="Helvetica"/>
               </a:rPr>
-              <a:t>6 September 2026  ·  https://github.com/padington/polar-codec</a:t>
+              <a:t>7 September 2026  ·  https://github.com/padington/polar-codec</a:t>
             </a:r>
           </a:p>
         </p:txBody>
@@ -3877,7 +3877,7 @@
                 </a:solidFill>
                 <a:latin typeface="Helvetica"/>
               </a:rPr>
-              <a:t>AV1 result: pending</a:t>
+              <a:t>AV1 result: the gap narrows, the verdict holds</a:t>
             </a:r>
           </a:p>
         </p:txBody>
@@ -3890,8 +3890,8 @@
         </p:nvSpPr>
         <p:spPr>
           <a:xfrm>
-            <a:off x="548640" y="1371600"/>
-            <a:ext cx="11094415" cy="1280160"/>
+            <a:off x="548640" y="6263640"/>
+            <a:ext cx="11094415" cy="457200"/>
           </a:xfrm>
           <a:prstGeom prst="rect">
             <a:avLst/>
@@ -3906,6 +3906,45 @@
           <a:p>
             <a:pPr algn="l">
               <a:spcAft>
+                <a:spcPts val="800"/>
+              </a:spcAft>
+            </a:pPr>
+            <a:r>
+              <a:rPr sz="1100" b="0">
+                <a:solidFill>
+                  <a:srgbClr val="9AA7B4"/>
+                </a:solidFill>
+                <a:latin typeface="Helvetica"/>
+              </a:rPr>
+              <a:t>Negative = polar needs fewer bytes than the square at the same quality. results/batch2_svtav1 (SVT-AV1 preset 6, PSNR tuning, 30 clips x 3 variants x 6 settings) and results/aom_ablation (libaom on the synthetic clips, global + warped motion on vs off).</a:t>
+            </a:r>
+          </a:p>
+        </p:txBody>
+      </p:sp>
+      <p:sp>
+        <p:nvSpPr>
+          <p:cNvPr id="4" name="TextBox 3"/>
+          <p:cNvSpPr txBox="1"/>
+          <p:nvPr/>
+        </p:nvSpPr>
+        <p:spPr>
+          <a:xfrm>
+            <a:off x="548640" y="1371600"/>
+            <a:ext cx="11094415" cy="1188720"/>
+          </a:xfrm>
+          <a:prstGeom prst="rect">
+            <a:avLst/>
+          </a:prstGeom>
+          <a:noFill/>
+        </p:spPr>
+        <p:txBody>
+          <a:bodyPr wrap="square" anchor="t" lIns="45720" rIns="45720">
+            <a:spAutoFit/>
+          </a:bodyPr>
+          <a:lstStyle/>
+          <a:p>
+            <a:pPr algn="l">
+              <a:spcAft>
                 <a:spcPts val="1200"/>
               </a:spcAft>
             </a:pPr>
@@ -3916,70 +3955,457 @@
                 </a:solidFill>
                 <a:latin typeface="Helvetica"/>
               </a:rPr>
-              <a:t>The same 30 circles are being re-run with AV1, a newer codec with bigger blocks and built-in turn-and-zoom tools (results/batch3_av1).</a:t>
-            </a:r>
-          </a:p>
-        </p:txBody>
-      </p:sp>
-      <p:sp>
-        <p:nvSpPr>
-          <p:cNvPr id="4" name="Rounded Rectangle 3"/>
-          <p:cNvSpPr/>
-          <p:nvPr/>
-        </p:nvSpPr>
-        <p:spPr>
-          <a:xfrm>
-            <a:off x="1371600" y="2926080"/>
-            <a:ext cx="9448495" cy="3017520"/>
-          </a:xfrm>
-          <a:prstGeom prst="roundRect">
+              <a:t>Same 30 circles under AV1 (SVT-AV1, and libaom with its rotation and zoom tools switched on and off). The square still wins on every real clip; polar keeps an edge only on a fast spin.</a:t>
+            </a:r>
+          </a:p>
+        </p:txBody>
+      </p:sp>
+      <p:graphicFrame>
+        <p:nvGraphicFramePr>
+          <p:cNvPr id="5" name="Table 4"/>
+          <p:cNvGraphicFramePr>
+            <a:graphicFrameLocks noGrp="1"/>
+          </p:cNvGraphicFramePr>
+          <p:nvPr/>
+        </p:nvGraphicFramePr>
+        <p:xfrm>
+          <a:off x="548640" y="2514600"/>
+          <a:ext cx="11064240" cy="2468880"/>
+        </p:xfrm>
+        <a:graphic>
+          <a:graphicData uri="http://schemas.openxmlformats.org/drawingml/2006/table">
+            <a:tbl>
+              <a:tblPr firstRow="1" bandRow="1">
+                <a:tableStyleId>{5C22544A-7EE6-4342-B048-85BDC9FD1C3A}</a:tableStyleId>
+              </a:tblPr>
+              <a:tblGrid>
+                <a:gridCol w="5760720"/>
+                <a:gridCol w="2194560"/>
+                <a:gridCol w="3108960"/>
+              </a:tblGrid>
+              <a:tr h="411480">
+                <a:tc>
+                  <a:txBody>
+                    <a:bodyPr/>
+                    <a:lstStyle/>
+                    <a:p>
+                      <a:pPr algn="l"/>
+                    </a:p>
+                  </a:txBody>
+                  <a:tcPr>
+                    <a:solidFill>
+                      <a:srgbClr val="151D27"/>
+                    </a:solidFill>
+                  </a:tcPr>
+                </a:tc>
+                <a:tc>
+                  <a:txBody>
+                    <a:bodyPr/>
+                    <a:lstStyle/>
+                    <a:p>
+                      <a:pPr algn="r"/>
+                      <a:r>
+                        <a:rPr sz="1400">
+                          <a:solidFill>
+                            <a:srgbClr val="9AA7B4"/>
+                          </a:solidFill>
+                        </a:rPr>
+                        <a:t>H.264 (x264)</a:t>
+                      </a:r>
+                    </a:p>
+                  </a:txBody>
+                  <a:tcPr>
+                    <a:solidFill>
+                      <a:srgbClr val="151D27"/>
+                    </a:solidFill>
+                  </a:tcPr>
+                </a:tc>
+                <a:tc>
+                  <a:txBody>
+                    <a:bodyPr/>
+                    <a:lstStyle/>
+                    <a:p>
+                      <a:pPr algn="r"/>
+                      <a:r>
+                        <a:rPr sz="1400">
+                          <a:solidFill>
+                            <a:srgbClr val="9AA7B4"/>
+                          </a:solidFill>
+                        </a:rPr>
+                        <a:t>AV1</a:t>
+                      </a:r>
+                    </a:p>
+                  </a:txBody>
+                  <a:tcPr>
+                    <a:solidFill>
+                      <a:srgbClr val="151D27"/>
+                    </a:solidFill>
+                  </a:tcPr>
+                </a:tc>
+              </a:tr>
+              <a:tr h="411480">
+                <a:tc>
+                  <a:txBody>
+                    <a:bodyPr/>
+                    <a:lstStyle/>
+                    <a:p>
+                      <a:pPr algn="l"/>
+                      <a:r>
+                        <a:rPr sz="1500">
+                          <a:solidFill>
+                            <a:srgbClr val="E6EDF3"/>
+                          </a:solidFill>
+                        </a:rPr>
+                        <a:t>polar strip, real clips: bytes vs square</a:t>
+                      </a:r>
+                    </a:p>
+                  </a:txBody>
+                  <a:tcPr>
+                    <a:solidFill>
+                      <a:srgbClr val="0B1016"/>
+                    </a:solidFill>
+                  </a:tcPr>
+                </a:tc>
+                <a:tc>
+                  <a:txBody>
+                    <a:bodyPr/>
+                    <a:lstStyle/>
+                    <a:p>
+                      <a:pPr algn="r"/>
+                      <a:r>
+                        <a:rPr sz="1500">
+                          <a:solidFill>
+                            <a:srgbClr val="E6EDF3"/>
+                          </a:solidFill>
+                        </a:rPr>
+                        <a:t>1.82x</a:t>
+                      </a:r>
+                    </a:p>
+                  </a:txBody>
+                  <a:tcPr>
+                    <a:solidFill>
+                      <a:srgbClr val="0B1016"/>
+                    </a:solidFill>
+                  </a:tcPr>
+                </a:tc>
+                <a:tc>
+                  <a:txBody>
+                    <a:bodyPr/>
+                    <a:lstStyle/>
+                    <a:p>
+                      <a:pPr algn="r"/>
+                      <a:r>
+                        <a:rPr sz="1500">
+                          <a:solidFill>
+                            <a:srgbClr val="F5A623"/>
+                          </a:solidFill>
+                        </a:rPr>
+                        <a:t>1.76x</a:t>
+                      </a:r>
+                    </a:p>
+                  </a:txBody>
+                  <a:tcPr>
+                    <a:solidFill>
+                      <a:srgbClr val="0B1016"/>
+                    </a:solidFill>
+                  </a:tcPr>
+                </a:tc>
+              </a:tr>
+              <a:tr h="411480">
+                <a:tc>
+                  <a:txBody>
+                    <a:bodyPr/>
+                    <a:lstStyle/>
+                    <a:p>
+                      <a:pPr algn="l"/>
+                      <a:r>
+                        <a:rPr sz="1500">
+                          <a:solidFill>
+                            <a:srgbClr val="E6EDF3"/>
+                          </a:solidFill>
+                        </a:rPr>
+                        <a:t>gentlest disc-to-square map, real clips</a:t>
+                      </a:r>
+                    </a:p>
+                  </a:txBody>
+                  <a:tcPr>
+                    <a:solidFill>
+                      <a:srgbClr val="151D27"/>
+                    </a:solidFill>
+                  </a:tcPr>
+                </a:tc>
+                <a:tc>
+                  <a:txBody>
+                    <a:bodyPr/>
+                    <a:lstStyle/>
+                    <a:p>
+                      <a:pPr algn="r"/>
+                      <a:r>
+                        <a:rPr sz="1500">
+                          <a:solidFill>
+                            <a:srgbClr val="E6EDF3"/>
+                          </a:solidFill>
+                        </a:rPr>
+                        <a:t>1.37x</a:t>
+                      </a:r>
+                    </a:p>
+                  </a:txBody>
+                  <a:tcPr>
+                    <a:solidFill>
+                      <a:srgbClr val="151D27"/>
+                    </a:solidFill>
+                  </a:tcPr>
+                </a:tc>
+                <a:tc>
+                  <a:txBody>
+                    <a:bodyPr/>
+                    <a:lstStyle/>
+                    <a:p>
+                      <a:pPr algn="r"/>
+                      <a:r>
+                        <a:rPr sz="1500">
+                          <a:solidFill>
+                            <a:srgbClr val="F5A623"/>
+                          </a:solidFill>
+                        </a:rPr>
+                        <a:t>1.19x</a:t>
+                      </a:r>
+                    </a:p>
+                  </a:txBody>
+                  <a:tcPr>
+                    <a:solidFill>
+                      <a:srgbClr val="151D27"/>
+                    </a:solidFill>
+                  </a:tcPr>
+                </a:tc>
+              </a:tr>
+              <a:tr h="411480">
+                <a:tc>
+                  <a:txBody>
+                    <a:bodyPr/>
+                    <a:lstStyle/>
+                    <a:p>
+                      <a:pPr algn="l"/>
+                      <a:r>
+                        <a:rPr sz="1500">
+                          <a:solidFill>
+                            <a:srgbClr val="E6EDF3"/>
+                          </a:solidFill>
+                        </a:rPr>
+                        <a:t>polar strip, fast spin (3 degrees per frame)</a:t>
+                      </a:r>
+                    </a:p>
+                  </a:txBody>
+                  <a:tcPr>
+                    <a:solidFill>
+                      <a:srgbClr val="0B1016"/>
+                    </a:solidFill>
+                  </a:tcPr>
+                </a:tc>
+                <a:tc>
+                  <a:txBody>
+                    <a:bodyPr/>
+                    <a:lstStyle/>
+                    <a:p>
+                      <a:pPr algn="r"/>
+                      <a:r>
+                        <a:rPr sz="1500">
+                          <a:solidFill>
+                            <a:srgbClr val="E6EDF3"/>
+                          </a:solidFill>
+                        </a:rPr>
+                        <a:t>-14 %</a:t>
+                      </a:r>
+                    </a:p>
+                  </a:txBody>
+                  <a:tcPr>
+                    <a:solidFill>
+                      <a:srgbClr val="0B1016"/>
+                    </a:solidFill>
+                  </a:tcPr>
+                </a:tc>
+                <a:tc>
+                  <a:txBody>
+                    <a:bodyPr/>
+                    <a:lstStyle/>
+                    <a:p>
+                      <a:pPr algn="r"/>
+                      <a:r>
+                        <a:rPr sz="1500">
+                          <a:solidFill>
+                            <a:srgbClr val="F5A623"/>
+                          </a:solidFill>
+                        </a:rPr>
+                        <a:t>-34 % (SVT-AV1)</a:t>
+                      </a:r>
+                    </a:p>
+                  </a:txBody>
+                  <a:tcPr>
+                    <a:solidFill>
+                      <a:srgbClr val="0B1016"/>
+                    </a:solidFill>
+                  </a:tcPr>
+                </a:tc>
+              </a:tr>
+              <a:tr h="411480">
+                <a:tc>
+                  <a:txBody>
+                    <a:bodyPr/>
+                    <a:lstStyle/>
+                    <a:p>
+                      <a:pPr algn="l"/>
+                      <a:r>
+                        <a:rPr sz="1500">
+                          <a:solidFill>
+                            <a:srgbClr val="E6EDF3"/>
+                          </a:solidFill>
+                        </a:rPr>
+                        <a:t>polar on fast spin with AV1's turn-and-zoom tools off / on (libaom)</a:t>
+                      </a:r>
+                    </a:p>
+                  </a:txBody>
+                  <a:tcPr>
+                    <a:solidFill>
+                      <a:srgbClr val="151D27"/>
+                    </a:solidFill>
+                  </a:tcPr>
+                </a:tc>
+                <a:tc>
+                  <a:txBody>
+                    <a:bodyPr/>
+                    <a:lstStyle/>
+                    <a:p>
+                      <a:pPr algn="r"/>
+                    </a:p>
+                  </a:txBody>
+                  <a:tcPr>
+                    <a:solidFill>
+                      <a:srgbClr val="151D27"/>
+                    </a:solidFill>
+                  </a:tcPr>
+                </a:tc>
+                <a:tc>
+                  <a:txBody>
+                    <a:bodyPr/>
+                    <a:lstStyle/>
+                    <a:p>
+                      <a:pPr algn="r"/>
+                      <a:r>
+                        <a:rPr sz="1500">
+                          <a:solidFill>
+                            <a:srgbClr val="F5A623"/>
+                          </a:solidFill>
+                        </a:rPr>
+                        <a:t>-32 % / -21 %</a:t>
+                      </a:r>
+                    </a:p>
+                  </a:txBody>
+                  <a:tcPr>
+                    <a:solidFill>
+                      <a:srgbClr val="151D27"/>
+                    </a:solidFill>
+                  </a:tcPr>
+                </a:tc>
+              </a:tr>
+              <a:tr h="411480">
+                <a:tc>
+                  <a:txBody>
+                    <a:bodyPr/>
+                    <a:lstStyle/>
+                    <a:p>
+                      <a:pPr algn="l"/>
+                      <a:r>
+                        <a:rPr sz="1500">
+                          <a:solidFill>
+                            <a:srgbClr val="E6EDF3"/>
+                          </a:solidFill>
+                        </a:rPr>
+                        <a:t>plain square on fast spin with those tools off (libaom)</a:t>
+                      </a:r>
+                    </a:p>
+                  </a:txBody>
+                  <a:tcPr>
+                    <a:solidFill>
+                      <a:srgbClr val="0B1016"/>
+                    </a:solidFill>
+                  </a:tcPr>
+                </a:tc>
+                <a:tc>
+                  <a:txBody>
+                    <a:bodyPr/>
+                    <a:lstStyle/>
+                    <a:p>
+                      <a:pPr algn="r"/>
+                    </a:p>
+                  </a:txBody>
+                  <a:tcPr>
+                    <a:solidFill>
+                      <a:srgbClr val="0B1016"/>
+                    </a:solidFill>
+                  </a:tcPr>
+                </a:tc>
+                <a:tc>
+                  <a:txBody>
+                    <a:bodyPr/>
+                    <a:lstStyle/>
+                    <a:p>
+                      <a:pPr algn="r"/>
+                      <a:r>
+                        <a:rPr sz="1500">
+                          <a:solidFill>
+                            <a:srgbClr val="F5A623"/>
+                          </a:solidFill>
+                        </a:rPr>
+                        <a:t>+20 % more bytes</a:t>
+                      </a:r>
+                    </a:p>
+                  </a:txBody>
+                  <a:tcPr>
+                    <a:solidFill>
+                      <a:srgbClr val="0B1016"/>
+                    </a:solidFill>
+                  </a:tcPr>
+                </a:tc>
+              </a:tr>
+            </a:tbl>
+          </a:graphicData>
+        </a:graphic>
+      </p:graphicFrame>
+      <p:sp>
+        <p:nvSpPr>
+          <p:cNvPr id="6" name="TextBox 5"/>
+          <p:cNvSpPr txBox="1"/>
+          <p:nvPr/>
+        </p:nvSpPr>
+        <p:spPr>
+          <a:xfrm>
+            <a:off x="548640" y="5257800"/>
+            <a:ext cx="11094415" cy="822960"/>
+          </a:xfrm>
+          <a:prstGeom prst="rect">
             <a:avLst/>
           </a:prstGeom>
           <a:noFill/>
-          <a:ln w="50800">
-            <a:solidFill>
-              <a:srgbClr val="F5A623"/>
-            </a:solidFill>
-            <a:prstDash val="dash"/>
-          </a:ln>
-        </p:spPr>
-        <p:style>
-          <a:lnRef idx="1">
-            <a:schemeClr val="accent1"/>
-          </a:lnRef>
-          <a:fillRef idx="3">
-            <a:schemeClr val="accent1"/>
-          </a:fillRef>
-          <a:effectRef idx="2">
-            <a:schemeClr val="accent1"/>
-          </a:effectRef>
-          <a:fontRef idx="minor">
-            <a:schemeClr val="lt1"/>
-          </a:fontRef>
-        </p:style>
-        <p:txBody>
-          <a:bodyPr rtlCol="0" anchor="ctr" wrap="square"/>
-          <a:lstStyle/>
-          <a:p>
-            <a:pPr algn="ctr"/>
-            <a:r>
-              <a:rPr sz="4000" b="1">
+        </p:spPr>
+        <p:txBody>
+          <a:bodyPr wrap="square" anchor="t" lIns="45720" rIns="45720">
+            <a:spAutoFit/>
+          </a:bodyPr>
+          <a:lstStyle/>
+          <a:p>
+            <a:pPr algn="l">
+              <a:spcAft>
+                <a:spcPts val="800"/>
+              </a:spcAft>
+            </a:pPr>
+            <a:r>
+              <a:rPr sz="1800" b="1">
                 <a:solidFill>
                   <a:srgbClr val="F5A623"/>
                 </a:solidFill>
-              </a:rPr>
-              <a:t>AV1 result: pending</a:t>
-            </a:r>
-          </a:p>
-          <a:p>
-            <a:pPr algn="ctr"/>
-            <a:r>
-              <a:rPr sz="1600">
-                <a:solidFill>
-                  <a:srgbClr val="9AA7B4"/>
-                </a:solidFill>
-              </a:rPr>
-              <a:t>Placeholder: replace this box with the batch3 bar chart (bytes vs square) when the run finishes.</a:t>
+                <a:latin typeface="Helvetica"/>
+              </a:rPr>
+              <a:t>AV1 closes part of the gap on the square, but at fast spin polar still wins; at realistic motion it still loses.</a:t>
             </a:r>
           </a:p>
         </p:txBody>
@@ -6477,7 +6903,7 @@
                 </a:solidFill>
                 <a:latin typeface="Helvetica"/>
               </a:rPr>
-              <a:t>Only if AV1 still fails on spin and zoom. Pending.</a:t>
+              <a:t>Measured: AV1's own turn-and-zoom tools leave polar a 21 % edge on a fast spin only, and real circles do not spin. Not worth building.</a:t>
             </a:r>
           </a:p>
         </p:txBody>
@@ -8367,6 +8793,22 @@
               <a:t>Controls isolate resampling, the inverse warp and the pixel budget from the codec's own loss.</a:t>
             </a:r>
           </a:p>
+          <a:p>
+            <a:pPr algn="l">
+              <a:spcAft>
+                <a:spcPts val="1200"/>
+              </a:spcAft>
+            </a:pPr>
+            <a:r>
+              <a:rPr sz="1700" b="0">
+                <a:solidFill>
+                  <a:srgbClr val="E6EDF3"/>
+                </a:solidFill>
+                <a:latin typeface="Helvetica"/>
+              </a:rPr>
+              <a:t>AV1 pass: the same clips and synthetic motions under SVT-AV1 (PSNR tuning, same masks and settings per variant); libaom with its global and warped motion switched on and off.</a:t>
+            </a:r>
+          </a:p>
         </p:txBody>
       </p:sp>
       <p:sp>
@@ -8505,7 +8947,7 @@
                 </a:solidFill>
                 <a:hlinkClick r:id="rId4"/>
               </a:rPr>
-              <a:t>Galleries (best / worst clips)</a:t>
+              <a:t>AV1 comparison (gap tables)</a:t>
             </a:r>
           </a:p>
         </p:txBody>
@@ -8539,7 +8981,7 @@
                 </a:solidFill>
                 <a:hlinkClick r:id="rId5"/>
               </a:rPr>
-              <a:t>Synthetic motion report</a:t>
+              <a:t>Galleries (best / worst clips)</a:t>
             </a:r>
           </a:p>
         </p:txBody>
@@ -8573,7 +9015,7 @@
                 </a:solidFill>
                 <a:hlinkClick r:id="rId6"/>
               </a:rPr>
-              <a:t>Bibliography (checked sources)</a:t>
+              <a:t>Synthetic motion report</a:t>
             </a:r>
           </a:p>
         </p:txBody>
@@ -8606,6 +9048,40 @@
                   <a:srgbClr val="4CC2FF"/>
                 </a:solidFill>
                 <a:hlinkClick r:id="rId7"/>
+              </a:rPr>
+              <a:t>Bibliography (checked sources)</a:t>
+            </a:r>
+          </a:p>
+        </p:txBody>
+      </p:sp>
+      <p:sp>
+        <p:nvSpPr>
+          <p:cNvPr id="11" name="TextBox 10"/>
+          <p:cNvSpPr txBox="1"/>
+          <p:nvPr/>
+        </p:nvSpPr>
+        <p:spPr>
+          <a:xfrm>
+            <a:off x="6949440" y="4663440"/>
+            <a:ext cx="4754880" cy="457200"/>
+          </a:xfrm>
+          <a:prstGeom prst="rect">
+            <a:avLst/>
+          </a:prstGeom>
+          <a:noFill/>
+        </p:spPr>
+        <p:txBody>
+          <a:bodyPr wrap="none">
+            <a:spAutoFit/>
+          </a:bodyPr>
+          <a:lstStyle/>
+          <a:p>
+            <a:r>
+              <a:rPr sz="1600">
+                <a:solidFill>
+                  <a:srgbClr val="4CC2FF"/>
+                </a:solidFill>
+                <a:hlinkClick r:id="rId8"/>
               </a:rPr>
               <a:t>Plain-words explainer</a:t>
             </a:r>

</xml_diff>

<commit_message>
Deck slide 12 and a Shapes section: six canvas shapes, both codecs, the corner-cost ceiling
The deck gains 'Other ways to unroll the disc' after the rescue slide (elliptical
p50/p75, ellip_full, FG-squircular, conformal, hybrid centre tile; +21.5 % to
+79.8 % under x264, +9.0 % to +35.2 % under SVT-AV1), and the results page gains a
Shapes section rendered from the sweep's plain-language report.
</commit_message>
<xml_diff>
--- a/slides/polar-codec.pptx
+++ b/slides/polar-codec.pptx
@@ -27,6 +27,7 @@
     <p:sldId id="275" r:id="rId26"/>
     <p:sldId id="276" r:id="rId27"/>
     <p:sldId id="277" r:id="rId28"/>
+    <p:sldId id="278" r:id="rId29"/>
   </p:sldIdLst>
   <p:sldSz cx="12191695" cy="6858000" type="screen4x3"/>
   <p:notesSz cx="6858000" cy="9144000"/>
@@ -3566,7 +3567,7 @@
                 </a:solidFill>
                 <a:latin typeface="Helvetica"/>
               </a:rPr>
-              <a:t>Synthetic motion: polar wins only on a fast spin</a:t>
+              <a:t>Other ways to unroll the disc</a:t>
             </a:r>
           </a:p>
         </p:txBody>
@@ -3579,8 +3580,8 @@
         </p:nvSpPr>
         <p:spPr>
           <a:xfrm>
-            <a:off x="548640" y="1371600"/>
-            <a:ext cx="11094415" cy="1097280"/>
+            <a:off x="548640" y="6263640"/>
+            <a:ext cx="11094415" cy="457200"/>
           </a:xfrm>
           <a:prstGeom prst="rect">
             <a:avLst/>
@@ -3595,6 +3596,45 @@
           <a:p>
             <a:pPr algn="l">
               <a:spcAft>
+                <a:spcPts val="800"/>
+              </a:spcAft>
+            </a:pPr>
+            <a:r>
+              <a:rPr sz="1100" b="0">
+                <a:solidFill>
+                  <a:srgbClr val="9AA7B4"/>
+                </a:solidFill>
+                <a:latin typeface="Helvetica"/>
+              </a:rPr>
+              <a:t>Positive = more bytes than the plain square at the same quality inside the circle (BD-rate, median over 12 clips of 10 s, 6 quality settings). results/batch4_shapes (x264) and results/batch4_shapes_svtav1 (SVT-AV1); the ceiling is the corner-cost oracle in results/batch4_shapes/shapes_report.md, section 3.</a:t>
+            </a:r>
+          </a:p>
+        </p:txBody>
+      </p:sp>
+      <p:sp>
+        <p:nvSpPr>
+          <p:cNvPr id="4" name="TextBox 3"/>
+          <p:cNvSpPr txBox="1"/>
+          <p:nvPr/>
+        </p:nvSpPr>
+        <p:spPr>
+          <a:xfrm>
+            <a:off x="548640" y="1371600"/>
+            <a:ext cx="11094415" cy="1188720"/>
+          </a:xfrm>
+          <a:prstGeom prst="rect">
+            <a:avLst/>
+          </a:prstGeom>
+          <a:noFill/>
+        </p:spPr>
+        <p:txBody>
+          <a:bodyPr wrap="square" anchor="t" lIns="45720" rIns="45720">
+            <a:spAutoFit/>
+          </a:bodyPr>
+          <a:lstStyle/>
+          <a:p>
+            <a:pPr algn="l">
+              <a:spcAft>
                 <a:spcPts val="1200"/>
               </a:spcAft>
             </a:pPr>
@@ -3605,35 +3645,592 @@
                 </a:solidFill>
                 <a:latin typeface="Helvetica"/>
               </a:rPr>
-              <a:t>Spinning 3 degrees per frame: -14 %. Everything people actually do (hold still, sway, lean in) costs more. Real circles are shaky and sideways, not spinning.</a:t>
-            </a:r>
-          </a:p>
-        </p:txBody>
-      </p:sp>
-      <p:pic>
-        <p:nvPicPr>
-          <p:cNvPr id="4" name="Picture 3" descr="fig_synth.png"/>
-          <p:cNvPicPr>
-            <a:picLocks noChangeAspect="1"/>
-          </p:cNvPicPr>
-          <p:nvPr/>
-        </p:nvPicPr>
-        <p:blipFill>
-          <a:blip r:embed="rId2"/>
-          <a:stretch>
-            <a:fillRect/>
-          </a:stretch>
-        </p:blipFill>
-        <p:spPr>
-          <a:xfrm>
-            <a:off x="1930249" y="2468880"/>
-            <a:ext cx="8331197" cy="3749039"/>
-          </a:xfrm>
-          <a:prstGeom prst="rect">
-            <a:avLst/>
-          </a:prstGeom>
-        </p:spPr>
-      </p:pic>
+              <a:t>Six canvases, 12 clips, both codecs: ellipses inflated half-way and all the way, a squircle, an angle-preserving conformal map, and a centre-tile hybrid. The less warped the canvas, the cheaper it is; the least warped is the square.</a:t>
+            </a:r>
+          </a:p>
+        </p:txBody>
+      </p:sp>
+      <p:graphicFrame>
+        <p:nvGraphicFramePr>
+          <p:cNvPr id="5" name="Table 4"/>
+          <p:cNvGraphicFramePr>
+            <a:graphicFrameLocks noGrp="1"/>
+          </p:cNvGraphicFramePr>
+          <p:nvPr/>
+        </p:nvGraphicFramePr>
+        <p:xfrm>
+          <a:off x="548640" y="2514600"/>
+          <a:ext cx="11064240" cy="2468880"/>
+        </p:xfrm>
+        <a:graphic>
+          <a:graphicData uri="http://schemas.openxmlformats.org/drawingml/2006/table">
+            <a:tbl>
+              <a:tblPr firstRow="1" bandRow="1">
+                <a:tableStyleId>{5C22544A-7EE6-4342-B048-85BDC9FD1C3A}</a:tableStyleId>
+              </a:tblPr>
+              <a:tblGrid>
+                <a:gridCol w="6766560"/>
+                <a:gridCol w="2194560"/>
+                <a:gridCol w="2103120"/>
+              </a:tblGrid>
+              <a:tr h="352697">
+                <a:tc>
+                  <a:txBody>
+                    <a:bodyPr/>
+                    <a:lstStyle/>
+                    <a:p>
+                      <a:pPr algn="l"/>
+                      <a:r>
+                        <a:rPr sz="1400">
+                          <a:solidFill>
+                            <a:srgbClr val="9AA7B4"/>
+                          </a:solidFill>
+                        </a:rPr>
+                        <a:t>shape (corners removed)</a:t>
+                      </a:r>
+                    </a:p>
+                  </a:txBody>
+                  <a:tcPr>
+                    <a:solidFill>
+                      <a:srgbClr val="151D27"/>
+                    </a:solidFill>
+                  </a:tcPr>
+                </a:tc>
+                <a:tc>
+                  <a:txBody>
+                    <a:bodyPr/>
+                    <a:lstStyle/>
+                    <a:p>
+                      <a:pPr algn="r"/>
+                      <a:r>
+                        <a:rPr sz="1400">
+                          <a:solidFill>
+                            <a:srgbClr val="9AA7B4"/>
+                          </a:solidFill>
+                        </a:rPr>
+                        <a:t>H.264 (x264)</a:t>
+                      </a:r>
+                    </a:p>
+                  </a:txBody>
+                  <a:tcPr>
+                    <a:solidFill>
+                      <a:srgbClr val="151D27"/>
+                    </a:solidFill>
+                  </a:tcPr>
+                </a:tc>
+                <a:tc>
+                  <a:txBody>
+                    <a:bodyPr/>
+                    <a:lstStyle/>
+                    <a:p>
+                      <a:pPr algn="r"/>
+                      <a:r>
+                        <a:rPr sz="1400">
+                          <a:solidFill>
+                            <a:srgbClr val="9AA7B4"/>
+                          </a:solidFill>
+                        </a:rPr>
+                        <a:t>AV1</a:t>
+                      </a:r>
+                    </a:p>
+                  </a:txBody>
+                  <a:tcPr>
+                    <a:solidFill>
+                      <a:srgbClr val="151D27"/>
+                    </a:solidFill>
+                  </a:tcPr>
+                </a:tc>
+              </a:tr>
+              <a:tr h="352697">
+                <a:tc>
+                  <a:txBody>
+                    <a:bodyPr/>
+                    <a:lstStyle/>
+                    <a:p>
+                      <a:pPr algn="l"/>
+                      <a:r>
+                        <a:rPr sz="1500">
+                          <a:solidFill>
+                            <a:srgbClr val="E6EDF3"/>
+                          </a:solidFill>
+                        </a:rPr>
+                        <a:t>elliptical, half-way (disc fills 85 % of the frame) — 25 %</a:t>
+                      </a:r>
+                    </a:p>
+                  </a:txBody>
+                  <a:tcPr>
+                    <a:solidFill>
+                      <a:srgbClr val="0B1016"/>
+                    </a:solidFill>
+                  </a:tcPr>
+                </a:tc>
+                <a:tc>
+                  <a:txBody>
+                    <a:bodyPr/>
+                    <a:lstStyle/>
+                    <a:p>
+                      <a:pPr algn="r"/>
+                      <a:r>
+                        <a:rPr sz="1500">
+                          <a:solidFill>
+                            <a:srgbClr val="F5A623"/>
+                          </a:solidFill>
+                        </a:rPr>
+                        <a:t>+21.5 %</a:t>
+                      </a:r>
+                    </a:p>
+                  </a:txBody>
+                  <a:tcPr>
+                    <a:solidFill>
+                      <a:srgbClr val="0B1016"/>
+                    </a:solidFill>
+                  </a:tcPr>
+                </a:tc>
+                <a:tc>
+                  <a:txBody>
+                    <a:bodyPr/>
+                    <a:lstStyle/>
+                    <a:p>
+                      <a:pPr algn="r"/>
+                      <a:r>
+                        <a:rPr sz="1500">
+                          <a:solidFill>
+                            <a:srgbClr val="F5A623"/>
+                          </a:solidFill>
+                        </a:rPr>
+                        <a:t>+9.0 %</a:t>
+                      </a:r>
+                    </a:p>
+                  </a:txBody>
+                  <a:tcPr>
+                    <a:solidFill>
+                      <a:srgbClr val="0B1016"/>
+                    </a:solidFill>
+                  </a:tcPr>
+                </a:tc>
+              </a:tr>
+              <a:tr h="352697">
+                <a:tc>
+                  <a:txBody>
+                    <a:bodyPr/>
+                    <a:lstStyle/>
+                    <a:p>
+                      <a:pPr algn="l"/>
+                      <a:r>
+                        <a:rPr sz="1500">
+                          <a:solidFill>
+                            <a:srgbClr val="E6EDF3"/>
+                          </a:solidFill>
+                        </a:rPr>
+                        <a:t>elliptical, three quarters — 50 %</a:t>
+                      </a:r>
+                    </a:p>
+                  </a:txBody>
+                  <a:tcPr>
+                    <a:solidFill>
+                      <a:srgbClr val="151D27"/>
+                    </a:solidFill>
+                  </a:tcPr>
+                </a:tc>
+                <a:tc>
+                  <a:txBody>
+                    <a:bodyPr/>
+                    <a:lstStyle/>
+                    <a:p>
+                      <a:pPr algn="r"/>
+                      <a:r>
+                        <a:rPr sz="1500">
+                          <a:solidFill>
+                            <a:srgbClr val="F5A623"/>
+                          </a:solidFill>
+                        </a:rPr>
+                        <a:t>+24.0 %</a:t>
+                      </a:r>
+                    </a:p>
+                  </a:txBody>
+                  <a:tcPr>
+                    <a:solidFill>
+                      <a:srgbClr val="151D27"/>
+                    </a:solidFill>
+                  </a:tcPr>
+                </a:tc>
+                <a:tc>
+                  <a:txBody>
+                    <a:bodyPr/>
+                    <a:lstStyle/>
+                    <a:p>
+                      <a:pPr algn="r"/>
+                      <a:r>
+                        <a:rPr sz="1500">
+                          <a:solidFill>
+                            <a:srgbClr val="F5A623"/>
+                          </a:solidFill>
+                        </a:rPr>
+                        <a:t>+9.6 %</a:t>
+                      </a:r>
+                    </a:p>
+                  </a:txBody>
+                  <a:tcPr>
+                    <a:solidFill>
+                      <a:srgbClr val="151D27"/>
+                    </a:solidFill>
+                  </a:tcPr>
+                </a:tc>
+              </a:tr>
+              <a:tr h="352697">
+                <a:tc>
+                  <a:txBody>
+                    <a:bodyPr/>
+                    <a:lstStyle/>
+                    <a:p>
+                      <a:pPr algn="l"/>
+                      <a:r>
+                        <a:rPr sz="1500">
+                          <a:solidFill>
+                            <a:srgbClr val="E6EDF3"/>
+                          </a:solidFill>
+                        </a:rPr>
+                        <a:t>elliptical, disc stretched to the full square — 100 %</a:t>
+                      </a:r>
+                    </a:p>
+                  </a:txBody>
+                  <a:tcPr>
+                    <a:solidFill>
+                      <a:srgbClr val="0B1016"/>
+                    </a:solidFill>
+                  </a:tcPr>
+                </a:tc>
+                <a:tc>
+                  <a:txBody>
+                    <a:bodyPr/>
+                    <a:lstStyle/>
+                    <a:p>
+                      <a:pPr algn="r"/>
+                      <a:r>
+                        <a:rPr sz="1500">
+                          <a:solidFill>
+                            <a:srgbClr val="F5A623"/>
+                          </a:solidFill>
+                        </a:rPr>
+                        <a:t>+35.0 %</a:t>
+                      </a:r>
+                    </a:p>
+                  </a:txBody>
+                  <a:tcPr>
+                    <a:solidFill>
+                      <a:srgbClr val="0B1016"/>
+                    </a:solidFill>
+                  </a:tcPr>
+                </a:tc>
+                <a:tc>
+                  <a:txBody>
+                    <a:bodyPr/>
+                    <a:lstStyle/>
+                    <a:p>
+                      <a:pPr algn="r"/>
+                      <a:r>
+                        <a:rPr sz="1500">
+                          <a:solidFill>
+                            <a:srgbClr val="F5A623"/>
+                          </a:solidFill>
+                        </a:rPr>
+                        <a:t>+17.3 %</a:t>
+                      </a:r>
+                    </a:p>
+                  </a:txBody>
+                  <a:tcPr>
+                    <a:solidFill>
+                      <a:srgbClr val="0B1016"/>
+                    </a:solidFill>
+                  </a:tcPr>
+                </a:tc>
+              </a:tr>
+              <a:tr h="352697">
+                <a:tc>
+                  <a:txBody>
+                    <a:bodyPr/>
+                    <a:lstStyle/>
+                    <a:p>
+                      <a:pPr algn="l"/>
+                      <a:r>
+                        <a:rPr sz="1500">
+                          <a:solidFill>
+                            <a:srgbClr val="E6EDF3"/>
+                          </a:solidFill>
+                        </a:rPr>
+                        <a:t>FG-squircular (squircle rings instead of ellipses) — 100 %</a:t>
+                      </a:r>
+                    </a:p>
+                  </a:txBody>
+                  <a:tcPr>
+                    <a:solidFill>
+                      <a:srgbClr val="151D27"/>
+                    </a:solidFill>
+                  </a:tcPr>
+                </a:tc>
+                <a:tc>
+                  <a:txBody>
+                    <a:bodyPr/>
+                    <a:lstStyle/>
+                    <a:p>
+                      <a:pPr algn="r"/>
+                      <a:r>
+                        <a:rPr sz="1500">
+                          <a:solidFill>
+                            <a:srgbClr val="F5A623"/>
+                          </a:solidFill>
+                        </a:rPr>
+                        <a:t>+36.3 %</a:t>
+                      </a:r>
+                    </a:p>
+                  </a:txBody>
+                  <a:tcPr>
+                    <a:solidFill>
+                      <a:srgbClr val="151D27"/>
+                    </a:solidFill>
+                  </a:tcPr>
+                </a:tc>
+                <a:tc>
+                  <a:txBody>
+                    <a:bodyPr/>
+                    <a:lstStyle/>
+                    <a:p>
+                      <a:pPr algn="r"/>
+                      <a:r>
+                        <a:rPr sz="1500">
+                          <a:solidFill>
+                            <a:srgbClr val="F5A623"/>
+                          </a:solidFill>
+                        </a:rPr>
+                        <a:t>+17.3 %</a:t>
+                      </a:r>
+                    </a:p>
+                  </a:txBody>
+                  <a:tcPr>
+                    <a:solidFill>
+                      <a:srgbClr val="151D27"/>
+                    </a:solidFill>
+                  </a:tcPr>
+                </a:tc>
+              </a:tr>
+              <a:tr h="352697">
+                <a:tc>
+                  <a:txBody>
+                    <a:bodyPr/>
+                    <a:lstStyle/>
+                    <a:p>
+                      <a:pPr algn="l"/>
+                      <a:r>
+                        <a:rPr sz="1500">
+                          <a:solidFill>
+                            <a:srgbClr val="E6EDF3"/>
+                          </a:solidFill>
+                        </a:rPr>
+                        <a:t>conformal (the only angle-preserving map) — 100 %</a:t>
+                      </a:r>
+                    </a:p>
+                  </a:txBody>
+                  <a:tcPr>
+                    <a:solidFill>
+                      <a:srgbClr val="0B1016"/>
+                    </a:solidFill>
+                  </a:tcPr>
+                </a:tc>
+                <a:tc>
+                  <a:txBody>
+                    <a:bodyPr/>
+                    <a:lstStyle/>
+                    <a:p>
+                      <a:pPr algn="r"/>
+                      <a:r>
+                        <a:rPr sz="1500">
+                          <a:solidFill>
+                            <a:srgbClr val="F5A623"/>
+                          </a:solidFill>
+                        </a:rPr>
+                        <a:t>+53.5 %</a:t>
+                      </a:r>
+                    </a:p>
+                  </a:txBody>
+                  <a:tcPr>
+                    <a:solidFill>
+                      <a:srgbClr val="0B1016"/>
+                    </a:solidFill>
+                  </a:tcPr>
+                </a:tc>
+                <a:tc>
+                  <a:txBody>
+                    <a:bodyPr/>
+                    <a:lstStyle/>
+                    <a:p>
+                      <a:pPr algn="r"/>
+                      <a:r>
+                        <a:rPr sz="1500">
+                          <a:solidFill>
+                            <a:srgbClr val="F5A623"/>
+                          </a:solidFill>
+                        </a:rPr>
+                        <a:t>+35.2 %</a:t>
+                      </a:r>
+                    </a:p>
+                  </a:txBody>
+                  <a:tcPr>
+                    <a:solidFill>
+                      <a:srgbClr val="0B1016"/>
+                    </a:solidFill>
+                  </a:tcPr>
+                </a:tc>
+              </a:tr>
+              <a:tr h="352698">
+                <a:tc>
+                  <a:txBody>
+                    <a:bodyPr/>
+                    <a:lstStyle/>
+                    <a:p>
+                      <a:pPr algn="l"/>
+                      <a:r>
+                        <a:rPr sz="1500">
+                          <a:solidFill>
+                            <a:srgbClr val="E6EDF3"/>
+                          </a:solidFill>
+                        </a:rPr>
+                        <a:t>hybrid: exact centre tile + polar rim packed below — 100 %</a:t>
+                      </a:r>
+                    </a:p>
+                  </a:txBody>
+                  <a:tcPr>
+                    <a:solidFill>
+                      <a:srgbClr val="151D27"/>
+                    </a:solidFill>
+                  </a:tcPr>
+                </a:tc>
+                <a:tc>
+                  <a:txBody>
+                    <a:bodyPr/>
+                    <a:lstStyle/>
+                    <a:p>
+                      <a:pPr algn="r"/>
+                      <a:r>
+                        <a:rPr sz="1500">
+                          <a:solidFill>
+                            <a:srgbClr val="F5A623"/>
+                          </a:solidFill>
+                        </a:rPr>
+                        <a:t>+79.8 %</a:t>
+                      </a:r>
+                    </a:p>
+                  </a:txBody>
+                  <a:tcPr>
+                    <a:solidFill>
+                      <a:srgbClr val="151D27"/>
+                    </a:solidFill>
+                  </a:tcPr>
+                </a:tc>
+                <a:tc>
+                  <a:txBody>
+                    <a:bodyPr/>
+                    <a:lstStyle/>
+                    <a:p>
+                      <a:pPr algn="r"/>
+                      <a:r>
+                        <a:rPr sz="1500">
+                          <a:solidFill>
+                            <a:srgbClr val="F5A623"/>
+                          </a:solidFill>
+                        </a:rPr>
+                        <a:t>not run</a:t>
+                      </a:r>
+                    </a:p>
+                  </a:txBody>
+                  <a:tcPr>
+                    <a:solidFill>
+                      <a:srgbClr val="151D27"/>
+                    </a:solidFill>
+                  </a:tcPr>
+                </a:tc>
+              </a:tr>
+            </a:tbl>
+          </a:graphicData>
+        </a:graphic>
+      </p:graphicFrame>
+      <p:sp>
+        <p:nvSpPr>
+          <p:cNvPr id="6" name="TextBox 5"/>
+          <p:cNvSpPr txBox="1"/>
+          <p:nvPr/>
+        </p:nvSpPr>
+        <p:spPr>
+          <a:xfrm>
+            <a:off x="548640" y="5029200"/>
+            <a:ext cx="11094415" cy="548640"/>
+          </a:xfrm>
+          <a:prstGeom prst="rect">
+            <a:avLst/>
+          </a:prstGeom>
+          <a:noFill/>
+        </p:spPr>
+        <p:txBody>
+          <a:bodyPr wrap="square" anchor="t" lIns="45720" rIns="45720">
+            <a:spAutoFit/>
+          </a:bodyPr>
+          <a:lstStyle/>
+          <a:p>
+            <a:pPr algn="l">
+              <a:spcAft>
+                <a:spcPts val="800"/>
+              </a:spcAft>
+            </a:pPr>
+            <a:r>
+              <a:rPr sz="1400" b="0">
+                <a:solidFill>
+                  <a:srgbClr val="9AA7B4"/>
+                </a:solidFill>
+                <a:latin typeface="Helvetica"/>
+              </a:rPr>
+              <a:t>Ceiling: whitening the real corners does not shrink the file (-0.3 to +2.5 %), and the corner region plus the disc edge is worth at most 1.9 to 8.5 % — the cheapest shape already costs +21.5 %.</a:t>
+            </a:r>
+          </a:p>
+        </p:txBody>
+      </p:sp>
+      <p:sp>
+        <p:nvSpPr>
+          <p:cNvPr id="7" name="TextBox 6"/>
+          <p:cNvSpPr txBox="1"/>
+          <p:nvPr/>
+        </p:nvSpPr>
+        <p:spPr>
+          <a:xfrm>
+            <a:off x="548640" y="5623560"/>
+            <a:ext cx="11094415" cy="411480"/>
+          </a:xfrm>
+          <a:prstGeom prst="rect">
+            <a:avLst/>
+          </a:prstGeom>
+          <a:noFill/>
+        </p:spPr>
+        <p:txBody>
+          <a:bodyPr wrap="square" anchor="t" lIns="45720" rIns="45720">
+            <a:spAutoFit/>
+          </a:bodyPr>
+          <a:lstStyle/>
+          <a:p>
+            <a:pPr algn="l">
+              <a:spcAft>
+                <a:spcPts val="800"/>
+              </a:spcAft>
+            </a:pPr>
+            <a:r>
+              <a:rPr sz="1700" b="1">
+                <a:solidFill>
+                  <a:srgbClr val="F5A623"/>
+                </a:solidFill>
+                <a:latin typeface="Helvetica"/>
+              </a:rPr>
+              <a:t>No shape wins on any clip under either codec, and the sweep's own trend points back to the square.</a:t>
+            </a:r>
+          </a:p>
+        </p:txBody>
+      </p:sp>
     </p:spTree>
   </p:cSld>
   <p:clrMapOvr>
@@ -3694,7 +4291,7 @@
                 </a:solidFill>
                 <a:latin typeface="Helvetica"/>
               </a:rPr>
-              <a:t>Where rotation and zoom already pay: inside the codec</a:t>
+              <a:t>Synthetic motion: polar wins only on a fast spin</a:t>
             </a:r>
           </a:p>
         </p:txBody>
@@ -3707,8 +4304,8 @@
         </p:nvSpPr>
         <p:spPr>
           <a:xfrm>
-            <a:off x="548640" y="6263640"/>
-            <a:ext cx="11094415" cy="457200"/>
+            <a:off x="548640" y="1371600"/>
+            <a:ext cx="11094415" cy="1097280"/>
           </a:xfrm>
           <a:prstGeom prst="rect">
             <a:avLst/>
@@ -3723,79 +4320,24 @@
           <a:p>
             <a:pPr algn="l">
               <a:spcAft>
-                <a:spcPts val="800"/>
-              </a:spcAft>
-            </a:pPr>
-            <a:r>
-              <a:rPr sz="1100" b="0">
-                <a:solidFill>
-                  <a:srgbClr val="9AA7B4"/>
-                </a:solidFill>
-                <a:latin typeface="Helvetica"/>
-              </a:rPr>
-              <a:t>Visionular libaom study; Parker et al. 2017; Li et al. 2018; Zhang et al. 2019; Yang et al. 2021.</a:t>
-            </a:r>
-          </a:p>
-        </p:txBody>
-      </p:sp>
-      <p:sp>
-        <p:nvSpPr>
-          <p:cNvPr id="4" name="TextBox 3"/>
-          <p:cNvSpPr txBox="1"/>
-          <p:nvPr/>
-        </p:nvSpPr>
-        <p:spPr>
-          <a:xfrm>
-            <a:off x="548640" y="1371600"/>
-            <a:ext cx="4023360" cy="4754880"/>
-          </a:xfrm>
-          <a:prstGeom prst="rect">
-            <a:avLst/>
-          </a:prstGeom>
-          <a:noFill/>
-        </p:spPr>
-        <p:txBody>
-          <a:bodyPr wrap="square" anchor="t" lIns="45720" rIns="45720">
-            <a:spAutoFit/>
-          </a:bodyPr>
-          <a:lstStyle/>
-          <a:p>
-            <a:pPr algn="l">
-              <a:spcAft>
                 <a:spcPts val="1200"/>
               </a:spcAft>
             </a:pPr>
             <a:r>
-              <a:rPr sz="1900" b="0">
+              <a:rPr sz="1800" b="0">
                 <a:solidFill>
                   <a:srgbClr val="E6EDF3"/>
                 </a:solidFill>
                 <a:latin typeface="Helvetica"/>
               </a:rPr>
-              <a:t>Newer codecs (AV1, VVC) already describe turn, zoom and shift with 4 to 6 numbers per block, on the square grid.</a:t>
-            </a:r>
-          </a:p>
-          <a:p>
-            <a:pPr algn="l">
-              <a:spcAft>
-                <a:spcPts val="1200"/>
-              </a:spcAft>
-            </a:pPr>
-            <a:r>
-              <a:rPr sz="1900" b="0">
-                <a:solidFill>
-                  <a:srgbClr val="E6EDF3"/>
-                </a:solidFill>
-                <a:latin typeface="Helvetica"/>
-              </a:rPr>
-              <a:t>Literature: about 1 % saved on average, 10 to 20 % only on rotation-heavy footage.</a:t>
+              <a:t>Spinning 3 degrees per frame: -14 %. Everything people actually do (hold still, sway, lean in) costs more. Real circles are shaky and sideways, not spinning.</a:t>
             </a:r>
           </a:p>
         </p:txBody>
       </p:sp>
       <p:pic>
         <p:nvPicPr>
-          <p:cNvPr id="5" name="Picture 4" descr="fig_affine.png"/>
+          <p:cNvPr id="4" name="Picture 3" descr="fig_synth.png"/>
           <p:cNvPicPr>
             <a:picLocks noChangeAspect="1"/>
           </p:cNvPicPr>
@@ -3809,8 +4351,8 @@
         </p:blipFill>
         <p:spPr>
           <a:xfrm>
-            <a:off x="4663440" y="1408176"/>
-            <a:ext cx="7315200" cy="4681728"/>
+            <a:off x="1930249" y="2468880"/>
+            <a:ext cx="8331197" cy="3749039"/>
           </a:xfrm>
           <a:prstGeom prst="rect">
             <a:avLst/>
@@ -3826,6 +4368,189 @@
 </file>
 
 <file path=ppt/slides/slide14.xml><?xml version="1.0" encoding="utf-8"?>
+<p:sld xmlns:a="http://schemas.openxmlformats.org/drawingml/2006/main" xmlns:p="http://schemas.openxmlformats.org/presentationml/2006/main" xmlns:r="http://schemas.openxmlformats.org/officeDocument/2006/relationships">
+  <p:cSld>
+    <p:bg>
+      <p:bgPr>
+        <a:solidFill>
+          <a:srgbClr val="0B1016"/>
+        </a:solidFill>
+        <a:effectLst/>
+      </p:bgPr>
+    </p:bg>
+    <p:spTree>
+      <p:nvGrpSpPr>
+        <p:cNvPr id="1" name=""/>
+        <p:cNvGrpSpPr/>
+        <p:nvPr/>
+      </p:nvGrpSpPr>
+      <p:grpSpPr/>
+      <p:sp>
+        <p:nvSpPr>
+          <p:cNvPr id="2" name="TextBox 1"/>
+          <p:cNvSpPr txBox="1"/>
+          <p:nvPr/>
+        </p:nvSpPr>
+        <p:spPr>
+          <a:xfrm>
+            <a:off x="548640" y="320040"/>
+            <a:ext cx="11094415" cy="914400"/>
+          </a:xfrm>
+          <a:prstGeom prst="rect">
+            <a:avLst/>
+          </a:prstGeom>
+          <a:noFill/>
+        </p:spPr>
+        <p:txBody>
+          <a:bodyPr wrap="square" anchor="t" lIns="45720" rIns="45720">
+            <a:spAutoFit/>
+          </a:bodyPr>
+          <a:lstStyle/>
+          <a:p>
+            <a:pPr algn="l">
+              <a:spcAft>
+                <a:spcPts val="800"/>
+              </a:spcAft>
+            </a:pPr>
+            <a:r>
+              <a:rPr sz="3400" b="1">
+                <a:solidFill>
+                  <a:srgbClr val="E6EDF3"/>
+                </a:solidFill>
+                <a:latin typeface="Helvetica"/>
+              </a:rPr>
+              <a:t>Where rotation and zoom already pay: inside the codec</a:t>
+            </a:r>
+          </a:p>
+        </p:txBody>
+      </p:sp>
+      <p:sp>
+        <p:nvSpPr>
+          <p:cNvPr id="3" name="TextBox 2"/>
+          <p:cNvSpPr txBox="1"/>
+          <p:nvPr/>
+        </p:nvSpPr>
+        <p:spPr>
+          <a:xfrm>
+            <a:off x="548640" y="6263640"/>
+            <a:ext cx="11094415" cy="457200"/>
+          </a:xfrm>
+          <a:prstGeom prst="rect">
+            <a:avLst/>
+          </a:prstGeom>
+          <a:noFill/>
+        </p:spPr>
+        <p:txBody>
+          <a:bodyPr wrap="square" anchor="t" lIns="45720" rIns="45720">
+            <a:spAutoFit/>
+          </a:bodyPr>
+          <a:lstStyle/>
+          <a:p>
+            <a:pPr algn="l">
+              <a:spcAft>
+                <a:spcPts val="800"/>
+              </a:spcAft>
+            </a:pPr>
+            <a:r>
+              <a:rPr sz="1100" b="0">
+                <a:solidFill>
+                  <a:srgbClr val="9AA7B4"/>
+                </a:solidFill>
+                <a:latin typeface="Helvetica"/>
+              </a:rPr>
+              <a:t>Visionular libaom study; Parker et al. 2017; Li et al. 2018; Zhang et al. 2019; Yang et al. 2021.</a:t>
+            </a:r>
+          </a:p>
+        </p:txBody>
+      </p:sp>
+      <p:sp>
+        <p:nvSpPr>
+          <p:cNvPr id="4" name="TextBox 3"/>
+          <p:cNvSpPr txBox="1"/>
+          <p:nvPr/>
+        </p:nvSpPr>
+        <p:spPr>
+          <a:xfrm>
+            <a:off x="548640" y="1371600"/>
+            <a:ext cx="4023360" cy="4754880"/>
+          </a:xfrm>
+          <a:prstGeom prst="rect">
+            <a:avLst/>
+          </a:prstGeom>
+          <a:noFill/>
+        </p:spPr>
+        <p:txBody>
+          <a:bodyPr wrap="square" anchor="t" lIns="45720" rIns="45720">
+            <a:spAutoFit/>
+          </a:bodyPr>
+          <a:lstStyle/>
+          <a:p>
+            <a:pPr algn="l">
+              <a:spcAft>
+                <a:spcPts val="1200"/>
+              </a:spcAft>
+            </a:pPr>
+            <a:r>
+              <a:rPr sz="1900" b="0">
+                <a:solidFill>
+                  <a:srgbClr val="E6EDF3"/>
+                </a:solidFill>
+                <a:latin typeface="Helvetica"/>
+              </a:rPr>
+              <a:t>Newer codecs (AV1, VVC) already describe turn, zoom and shift with 4 to 6 numbers per block, on the square grid.</a:t>
+            </a:r>
+          </a:p>
+          <a:p>
+            <a:pPr algn="l">
+              <a:spcAft>
+                <a:spcPts val="1200"/>
+              </a:spcAft>
+            </a:pPr>
+            <a:r>
+              <a:rPr sz="1900" b="0">
+                <a:solidFill>
+                  <a:srgbClr val="E6EDF3"/>
+                </a:solidFill>
+                <a:latin typeface="Helvetica"/>
+              </a:rPr>
+              <a:t>Literature: about 1 % saved on average, 10 to 20 % only on rotation-heavy footage.</a:t>
+            </a:r>
+          </a:p>
+        </p:txBody>
+      </p:sp>
+      <p:pic>
+        <p:nvPicPr>
+          <p:cNvPr id="5" name="Picture 4" descr="fig_affine.png"/>
+          <p:cNvPicPr>
+            <a:picLocks noChangeAspect="1"/>
+          </p:cNvPicPr>
+          <p:nvPr/>
+        </p:nvPicPr>
+        <p:blipFill>
+          <a:blip r:embed="rId2"/>
+          <a:stretch>
+            <a:fillRect/>
+          </a:stretch>
+        </p:blipFill>
+        <p:spPr>
+          <a:xfrm>
+            <a:off x="4663440" y="1408176"/>
+            <a:ext cx="7315200" cy="4681728"/>
+          </a:xfrm>
+          <a:prstGeom prst="rect">
+            <a:avLst/>
+          </a:prstGeom>
+        </p:spPr>
+      </p:pic>
+    </p:spTree>
+  </p:cSld>
+  <p:clrMapOvr>
+    <a:masterClrMapping/>
+  </p:clrMapOvr>
+</p:sld>
+</file>
+
+<file path=ppt/slides/slide15.xml><?xml version="1.0" encoding="utf-8"?>
 <p:sld xmlns:a="http://schemas.openxmlformats.org/drawingml/2006/main" xmlns:p="http://schemas.openxmlformats.org/presentationml/2006/main" xmlns:r="http://schemas.openxmlformats.org/officeDocument/2006/relationships">
   <p:cSld>
     <p:bg>
@@ -4418,383 +5143,6 @@
 </p:sld>
 </file>
 
-<file path=ppt/slides/slide15.xml><?xml version="1.0" encoding="utf-8"?>
-<p:sld xmlns:a="http://schemas.openxmlformats.org/drawingml/2006/main" xmlns:p="http://schemas.openxmlformats.org/presentationml/2006/main" xmlns:r="http://schemas.openxmlformats.org/officeDocument/2006/relationships">
-  <p:cSld>
-    <p:bg>
-      <p:bgPr>
-        <a:solidFill>
-          <a:srgbClr val="0B1016"/>
-        </a:solidFill>
-        <a:effectLst/>
-      </p:bgPr>
-    </p:bg>
-    <p:spTree>
-      <p:nvGrpSpPr>
-        <p:cNvPr id="1" name=""/>
-        <p:cNvGrpSpPr/>
-        <p:nvPr/>
-      </p:nvGrpSpPr>
-      <p:grpSpPr/>
-      <p:sp>
-        <p:nvSpPr>
-          <p:cNvPr id="2" name="TextBox 1"/>
-          <p:cNvSpPr txBox="1"/>
-          <p:nvPr/>
-        </p:nvSpPr>
-        <p:spPr>
-          <a:xfrm>
-            <a:off x="548640" y="320040"/>
-            <a:ext cx="11094415" cy="914400"/>
-          </a:xfrm>
-          <a:prstGeom prst="rect">
-            <a:avLst/>
-          </a:prstGeom>
-          <a:noFill/>
-        </p:spPr>
-        <p:txBody>
-          <a:bodyPr wrap="square" anchor="t" lIns="45720" rIns="45720">
-            <a:spAutoFit/>
-          </a:bodyPr>
-          <a:lstStyle/>
-          <a:p>
-            <a:pPr algn="l">
-              <a:spcAft>
-                <a:spcPts val="800"/>
-              </a:spcAft>
-            </a:pPr>
-            <a:r>
-              <a:rPr sz="3400" b="1">
-                <a:solidFill>
-                  <a:srgbClr val="E6EDF3"/>
-                </a:solidFill>
-                <a:latin typeface="Helvetica"/>
-              </a:rPr>
-              <a:t>What others tried: polar in video (1 of 2)</a:t>
-            </a:r>
-          </a:p>
-        </p:txBody>
-      </p:sp>
-      <p:sp>
-        <p:nvSpPr>
-          <p:cNvPr id="3" name="TextBox 2"/>
-          <p:cNvSpPr txBox="1"/>
-          <p:nvPr/>
-        </p:nvSpPr>
-        <p:spPr>
-          <a:xfrm>
-            <a:off x="548640" y="6263640"/>
-            <a:ext cx="11094415" cy="457200"/>
-          </a:xfrm>
-          <a:prstGeom prst="rect">
-            <a:avLst/>
-          </a:prstGeom>
-          <a:noFill/>
-        </p:spPr>
-        <p:txBody>
-          <a:bodyPr wrap="square" anchor="t" lIns="45720" rIns="45720">
-            <a:spAutoFit/>
-          </a:bodyPr>
-          <a:lstStyle/>
-          <a:p>
-            <a:pPr algn="l">
-              <a:spcAft>
-                <a:spcPts val="800"/>
-              </a:spcAft>
-            </a:pPr>
-            <a:r>
-              <a:rPr sz="1100" b="0">
-                <a:solidFill>
-                  <a:srgbClr val="9AA7B4"/>
-                </a:solidFill>
-                <a:latin typeface="Helvetica"/>
-              </a:rPr>
-              <a:t>Numbers and links: docs/research/polar-coding-literature.md, lens 1.</a:t>
-            </a:r>
-          </a:p>
-        </p:txBody>
-      </p:sp>
-      <p:sp>
-        <p:nvSpPr>
-          <p:cNvPr id="4" name="TextBox 3"/>
-          <p:cNvSpPr txBox="1"/>
-          <p:nvPr/>
-        </p:nvSpPr>
-        <p:spPr>
-          <a:xfrm>
-            <a:off x="548640" y="1371600"/>
-            <a:ext cx="11094415" cy="640080"/>
-          </a:xfrm>
-          <a:prstGeom prst="rect">
-            <a:avLst/>
-          </a:prstGeom>
-          <a:noFill/>
-        </p:spPr>
-        <p:txBody>
-          <a:bodyPr wrap="square" anchor="t" lIns="45720" rIns="45720">
-            <a:spAutoFit/>
-          </a:bodyPr>
-          <a:lstStyle/>
-          <a:p>
-            <a:pPr algn="l">
-              <a:spcAft>
-                <a:spcPts val="800"/>
-              </a:spcAft>
-            </a:pPr>
-            <a:r>
-              <a:rPr sz="1800" b="0">
-                <a:solidFill>
-                  <a:srgbClr val="9AA7B4"/>
-                </a:solidFill>
-                <a:latin typeface="Helvetica"/>
-              </a:rPr>
-              <a:t>Log-polar = polar with rings that widen toward the rim, like the eye's retina.</a:t>
-            </a:r>
-          </a:p>
-        </p:txBody>
-      </p:sp>
-      <p:sp>
-        <p:nvSpPr>
-          <p:cNvPr id="5" name="TextBox 4"/>
-          <p:cNvSpPr txBox="1"/>
-          <p:nvPr/>
-        </p:nvSpPr>
-        <p:spPr>
-          <a:xfrm>
-            <a:off x="548640" y="2103120"/>
-            <a:ext cx="4206240" cy="914400"/>
-          </a:xfrm>
-          <a:prstGeom prst="rect">
-            <a:avLst/>
-          </a:prstGeom>
-          <a:noFill/>
-        </p:spPr>
-        <p:txBody>
-          <a:bodyPr wrap="square" anchor="t" lIns="45720" rIns="45720">
-            <a:spAutoFit/>
-          </a:bodyPr>
-          <a:lstStyle/>
-          <a:p>
-            <a:pPr algn="l">
-              <a:spcAft>
-                <a:spcPts val="800"/>
-              </a:spcAft>
-            </a:pPr>
-            <a:r>
-              <a:rPr sz="2000" b="0">
-                <a:solidFill>
-                  <a:srgbClr val="4CC2FF"/>
-                </a:solidFill>
-                <a:latin typeface="Helvetica"/>
-              </a:rPr>
-              <a:t>Weiman 1990, log-polar video</a:t>
-            </a:r>
-          </a:p>
-        </p:txBody>
-      </p:sp>
-      <p:sp>
-        <p:nvSpPr>
-          <p:cNvPr id="6" name="TextBox 5"/>
-          <p:cNvSpPr txBox="1"/>
-          <p:nvPr/>
-        </p:nvSpPr>
-        <p:spPr>
-          <a:xfrm>
-            <a:off x="4846320" y="2103120"/>
-            <a:ext cx="6796735" cy="914400"/>
-          </a:xfrm>
-          <a:prstGeom prst="rect">
-            <a:avLst/>
-          </a:prstGeom>
-          <a:noFill/>
-        </p:spPr>
-        <p:txBody>
-          <a:bodyPr wrap="square" anchor="t" lIns="45720" rIns="45720">
-            <a:spAutoFit/>
-          </a:bodyPr>
-          <a:lstStyle/>
-          <a:p>
-            <a:pPr algn="l">
-              <a:spcAft>
-                <a:spcPts val="800"/>
-              </a:spcAft>
-            </a:pPr>
-            <a:r>
-              <a:rPr sz="2000" b="0">
-                <a:solidFill>
-                  <a:srgbClr val="E6EDF3"/>
-                </a:solidFill>
-                <a:latin typeface="Helvetica"/>
-              </a:rPr>
-              <a:t>the saving came from dropping rim detail, not from geometry.</a:t>
-            </a:r>
-          </a:p>
-        </p:txBody>
-      </p:sp>
-      <p:sp>
-        <p:nvSpPr>
-          <p:cNvPr id="7" name="TextBox 6"/>
-          <p:cNvSpPr txBox="1"/>
-          <p:nvPr/>
-        </p:nvSpPr>
-        <p:spPr>
-          <a:xfrm>
-            <a:off x="548640" y="3154680"/>
-            <a:ext cx="4206240" cy="914400"/>
-          </a:xfrm>
-          <a:prstGeom prst="rect">
-            <a:avLst/>
-          </a:prstGeom>
-          <a:noFill/>
-        </p:spPr>
-        <p:txBody>
-          <a:bodyPr wrap="square" anchor="t" lIns="45720" rIns="45720">
-            <a:spAutoFit/>
-          </a:bodyPr>
-          <a:lstStyle/>
-          <a:p>
-            <a:pPr algn="l">
-              <a:spcAft>
-                <a:spcPts val="800"/>
-              </a:spcAft>
-            </a:pPr>
-            <a:r>
-              <a:rPr sz="2000" b="0">
-                <a:solidFill>
-                  <a:srgbClr val="4CC2FF"/>
-                </a:solidFill>
-                <a:latin typeface="Helvetica"/>
-              </a:rPr>
-              <a:t>Li et al. 2021, log-polar strip into a standard codec</a:t>
-            </a:r>
-          </a:p>
-        </p:txBody>
-      </p:sp>
-      <p:sp>
-        <p:nvSpPr>
-          <p:cNvPr id="8" name="TextBox 7"/>
-          <p:cNvSpPr txBox="1"/>
-          <p:nvPr/>
-        </p:nvSpPr>
-        <p:spPr>
-          <a:xfrm>
-            <a:off x="4846320" y="3154680"/>
-            <a:ext cx="6796735" cy="914400"/>
-          </a:xfrm>
-          <a:prstGeom prst="rect">
-            <a:avLst/>
-          </a:prstGeom>
-          <a:noFill/>
-        </p:spPr>
-        <p:txBody>
-          <a:bodyPr wrap="square" anchor="t" lIns="45720" rIns="45720">
-            <a:spAutoFit/>
-          </a:bodyPr>
-          <a:lstStyle/>
-          <a:p>
-            <a:pPr algn="l">
-              <a:spcAft>
-                <a:spcPts val="800"/>
-              </a:spcAft>
-            </a:pPr>
-            <a:r>
-              <a:rPr sz="2000" b="0">
-                <a:solidFill>
-                  <a:srgbClr val="E6EDF3"/>
-                </a:solidFill>
-                <a:latin typeface="Helvetica"/>
-              </a:rPr>
-              <a:t>it flickers; a straighter warp was cheaper.</a:t>
-            </a:r>
-          </a:p>
-        </p:txBody>
-      </p:sp>
-      <p:sp>
-        <p:nvSpPr>
-          <p:cNvPr id="9" name="TextBox 8"/>
-          <p:cNvSpPr txBox="1"/>
-          <p:nvPr/>
-        </p:nvSpPr>
-        <p:spPr>
-          <a:xfrm>
-            <a:off x="548640" y="4206240"/>
-            <a:ext cx="4206240" cy="914400"/>
-          </a:xfrm>
-          <a:prstGeom prst="rect">
-            <a:avLst/>
-          </a:prstGeom>
-          <a:noFill/>
-        </p:spPr>
-        <p:txBody>
-          <a:bodyPr wrap="square" anchor="t" lIns="45720" rIns="45720">
-            <a:spAutoFit/>
-          </a:bodyPr>
-          <a:lstStyle/>
-          <a:p>
-            <a:pPr algn="l">
-              <a:spcAft>
-                <a:spcPts val="800"/>
-              </a:spcAft>
-            </a:pPr>
-            <a:r>
-              <a:rPr sz="2000" b="0">
-                <a:solidFill>
-                  <a:srgbClr val="4CC2FF"/>
-                </a:solidFill>
-                <a:latin typeface="Helvetica"/>
-              </a:rPr>
-              <a:t>Eichenseer &amp; Kaup 2014-2019, fisheye video</a:t>
-            </a:r>
-          </a:p>
-        </p:txBody>
-      </p:sp>
-      <p:sp>
-        <p:nvSpPr>
-          <p:cNvPr id="10" name="TextBox 9"/>
-          <p:cNvSpPr txBox="1"/>
-          <p:nvPr/>
-        </p:nvSpPr>
-        <p:spPr>
-          <a:xfrm>
-            <a:off x="4846320" y="4206240"/>
-            <a:ext cx="6796735" cy="914400"/>
-          </a:xfrm>
-          <a:prstGeom prst="rect">
-            <a:avLst/>
-          </a:prstGeom>
-          <a:noFill/>
-        </p:spPr>
-        <p:txBody>
-          <a:bodyPr wrap="square" anchor="t" lIns="45720" rIns="45720">
-            <a:spAutoFit/>
-          </a:bodyPr>
-          <a:lstStyle/>
-          <a:p>
-            <a:pPr algn="l">
-              <a:spcAft>
-                <a:spcPts val="800"/>
-              </a:spcAft>
-            </a:pPr>
-            <a:r>
-              <a:rPr sz="2000" b="0">
-                <a:solidFill>
-                  <a:srgbClr val="E6EDF3"/>
-                </a:solidFill>
-                <a:latin typeface="Helvetica"/>
-              </a:rPr>
-              <a:t>straightening curved lines helped, about 1 dB.</a:t>
-            </a:r>
-          </a:p>
-        </p:txBody>
-      </p:sp>
-    </p:spTree>
-  </p:cSld>
-  <p:clrMapOvr>
-    <a:masterClrMapping/>
-  </p:clrMapOvr>
-</p:sld>
-</file>
-
 <file path=ppt/slides/slide16.xml><?xml version="1.0" encoding="utf-8"?>
 <p:sld xmlns:a="http://schemas.openxmlformats.org/drawingml/2006/main" xmlns:p="http://schemas.openxmlformats.org/presentationml/2006/main" xmlns:r="http://schemas.openxmlformats.org/officeDocument/2006/relationships">
   <p:cSld>
@@ -4847,7 +5195,7 @@
                 </a:solidFill>
                 <a:latin typeface="Helvetica"/>
               </a:rPr>
-              <a:t>What others tried: polar in video (2 of 2)</a:t>
+              <a:t>What others tried: polar in video (1 of 2)</a:t>
             </a:r>
           </a:p>
         </p:txBody>
@@ -4900,7 +5248,7 @@
         <p:spPr>
           <a:xfrm>
             <a:off x="548640" y="1371600"/>
-            <a:ext cx="4206240" cy="914400"/>
+            <a:ext cx="11094415" cy="640080"/>
           </a:xfrm>
           <a:prstGeom prst="rect">
             <a:avLst/>
@@ -4919,13 +5267,13 @@
               </a:spcAft>
             </a:pPr>
             <a:r>
-              <a:rPr sz="2000" b="0">
-                <a:solidFill>
-                  <a:srgbClr val="4CC2FF"/>
-                </a:solidFill>
-                <a:latin typeface="Helvetica"/>
-              </a:rPr>
-              <a:t>Vishwanath et al. 2018, 360-degree video</a:t>
+              <a:rPr sz="1800" b="0">
+                <a:solidFill>
+                  <a:srgbClr val="9AA7B4"/>
+                </a:solidFill>
+                <a:latin typeface="Helvetica"/>
+              </a:rPr>
+              <a:t>Log-polar = polar with rings that widen toward the rim, like the eye's retina.</a:t>
             </a:r>
           </a:p>
         </p:txBody>
@@ -4938,8 +5286,8 @@
         </p:nvSpPr>
         <p:spPr>
           <a:xfrm>
-            <a:off x="4846320" y="1371600"/>
-            <a:ext cx="6796735" cy="914400"/>
+            <a:off x="548640" y="2103120"/>
+            <a:ext cx="4206240" cy="914400"/>
           </a:xfrm>
           <a:prstGeom prst="rect">
             <a:avLst/>
@@ -4960,11 +5308,11 @@
             <a:r>
               <a:rPr sz="2000" b="0">
                 <a:solidFill>
-                  <a:srgbClr val="E6EDF3"/>
-                </a:solidFill>
-                <a:latin typeface="Helvetica"/>
-              </a:rPr>
-              <a:t>a rotation model helps only on far more warped pictures.</a:t>
+                  <a:srgbClr val="4CC2FF"/>
+                </a:solidFill>
+                <a:latin typeface="Helvetica"/>
+              </a:rPr>
+              <a:t>Weiman 1990, log-polar video</a:t>
             </a:r>
           </a:p>
         </p:txBody>
@@ -4977,8 +5325,8 @@
         </p:nvSpPr>
         <p:spPr>
           <a:xfrm>
-            <a:off x="548640" y="2423160"/>
-            <a:ext cx="4206240" cy="914400"/>
+            <a:off x="4846320" y="2103120"/>
+            <a:ext cx="6796735" cy="914400"/>
           </a:xfrm>
           <a:prstGeom prst="rect">
             <a:avLst/>
@@ -4999,11 +5347,11 @@
             <a:r>
               <a:rPr sz="2000" b="0">
                 <a:solidFill>
-                  <a:srgbClr val="4CC2FF"/>
-                </a:solidFill>
-                <a:latin typeface="Helvetica"/>
-              </a:rPr>
-              <a:t>Ahmmed et al. 2016, fully bendable motion</a:t>
+                  <a:srgbClr val="E6EDF3"/>
+                </a:solidFill>
+                <a:latin typeface="Helvetica"/>
+              </a:rPr>
+              <a:t>the saving came from dropping rim detail, not from geometry.</a:t>
             </a:r>
           </a:p>
         </p:txBody>
@@ -5016,8 +5364,8 @@
         </p:nvSpPr>
         <p:spPr>
           <a:xfrm>
-            <a:off x="4846320" y="2423160"/>
-            <a:ext cx="6796735" cy="914400"/>
+            <a:off x="548640" y="3154680"/>
+            <a:ext cx="4206240" cy="914400"/>
           </a:xfrm>
           <a:prstGeom prst="rect">
             <a:avLst/>
@@ -5038,11 +5386,11 @@
             <a:r>
               <a:rPr sz="2000" b="0">
                 <a:solidFill>
-                  <a:srgbClr val="E6EDF3"/>
-                </a:solidFill>
-                <a:latin typeface="Helvetica"/>
-              </a:rPr>
-              <a:t>small gain, and only on round wide-angle footage.</a:t>
+                  <a:srgbClr val="4CC2FF"/>
+                </a:solidFill>
+                <a:latin typeface="Helvetica"/>
+              </a:rPr>
+              <a:t>Li et al. 2021, log-polar strip into a standard codec</a:t>
             </a:r>
           </a:p>
         </p:txBody>
@@ -5055,8 +5403,8 @@
         </p:nvSpPr>
         <p:spPr>
           <a:xfrm>
-            <a:off x="548640" y="3474720"/>
-            <a:ext cx="4206240" cy="914400"/>
+            <a:off x="4846320" y="3154680"/>
+            <a:ext cx="6796735" cy="914400"/>
           </a:xfrm>
           <a:prstGeom prst="rect">
             <a:avLst/>
@@ -5077,11 +5425,11 @@
             <a:r>
               <a:rPr sz="2000" b="0">
                 <a:solidFill>
-                  <a:srgbClr val="4CC2FF"/>
-                </a:solidFill>
-                <a:latin typeface="Helvetica"/>
-              </a:rPr>
-              <a:t>Schwarz &amp; Behnke 2025, telepresence</a:t>
+                  <a:srgbClr val="E6EDF3"/>
+                </a:solidFill>
+                <a:latin typeface="Helvetica"/>
+              </a:rPr>
+              <a:t>it flickers; a straighter warp was cheaper.</a:t>
             </a:r>
           </a:p>
         </p:txBody>
@@ -5094,8 +5442,8 @@
         </p:nvSpPr>
         <p:spPr>
           <a:xfrm>
-            <a:off x="4846320" y="3474720"/>
-            <a:ext cx="6796735" cy="914400"/>
+            <a:off x="548640" y="4206240"/>
+            <a:ext cx="4206240" cy="914400"/>
           </a:xfrm>
           <a:prstGeom prst="rect">
             <a:avLst/>
@@ -5116,11 +5464,11 @@
             <a:r>
               <a:rPr sz="2000" b="0">
                 <a:solidFill>
-                  <a:srgbClr val="E6EDF3"/>
-                </a:solidFill>
-                <a:latin typeface="Helvetica"/>
-              </a:rPr>
-              <a:t>a quality map in a stock codec beat warping the pixels.</a:t>
+                  <a:srgbClr val="4CC2FF"/>
+                </a:solidFill>
+                <a:latin typeface="Helvetica"/>
+              </a:rPr>
+              <a:t>Eichenseer &amp; Kaup 2014-2019, fisheye video</a:t>
             </a:r>
           </a:p>
         </p:txBody>
@@ -5133,8 +5481,8 @@
         </p:nvSpPr>
         <p:spPr>
           <a:xfrm>
-            <a:off x="548640" y="4709160"/>
-            <a:ext cx="11094415" cy="548640"/>
+            <a:off x="4846320" y="4206240"/>
+            <a:ext cx="6796735" cy="914400"/>
           </a:xfrm>
           <a:prstGeom prst="rect">
             <a:avLst/>
@@ -5153,13 +5501,13 @@
               </a:spcAft>
             </a:pPr>
             <a:r>
-              <a:rPr sz="2000" b="1">
-                <a:solidFill>
-                  <a:srgbClr val="F5A623"/>
-                </a:solidFill>
-                <a:latin typeface="Helvetica"/>
-              </a:rPr>
-              <a:t>Six sources, none beat the square grid.</a:t>
+              <a:rPr sz="2000" b="0">
+                <a:solidFill>
+                  <a:srgbClr val="E6EDF3"/>
+                </a:solidFill>
+                <a:latin typeface="Helvetica"/>
+              </a:rPr>
+              <a:t>straightening curved lines helped, about 1 dB.</a:t>
             </a:r>
           </a:p>
         </p:txBody>
@@ -5224,7 +5572,7 @@
                 </a:solidFill>
                 <a:latin typeface="Helvetica"/>
               </a:rPr>
-              <a:t>What others tried: polar for still images (1 of 2)</a:t>
+              <a:t>What others tried: polar in video (2 of 2)</a:t>
             </a:r>
           </a:p>
         </p:txBody>
@@ -5263,7 +5611,7 @@
                 </a:solidFill>
                 <a:latin typeface="Helvetica"/>
               </a:rPr>
-              <a:t>Numbers and links: docs/research/polar-coding-literature.md, lens 2.</a:t>
+              <a:t>Numbers and links: docs/research/polar-coding-literature.md, lens 1.</a:t>
             </a:r>
           </a:p>
         </p:txBody>
@@ -5302,7 +5650,7 @@
                 </a:solidFill>
                 <a:latin typeface="Helvetica"/>
               </a:rPr>
-              <a:t>Log-polar retina sensors (Sandini, Berton 2006)</a:t>
+              <a:t>Vishwanath et al. 2018, 360-degree video</a:t>
             </a:r>
           </a:p>
         </p:txBody>
@@ -5341,7 +5689,7 @@
                 </a:solidFill>
                 <a:latin typeface="Helvetica"/>
               </a:rPr>
-              <a:t>fewer pixels toward the rim; never became a product.</a:t>
+              <a:t>a rotation model helps only on far more warped pictures.</a:t>
             </a:r>
           </a:p>
         </p:txBody>
@@ -5380,7 +5728,7 @@
                 </a:solidFill>
                 <a:latin typeface="Helvetica"/>
               </a:rPr>
-              <a:t>Iris rubber-sheet format, ISO 19794-6 (2005)</a:t>
+              <a:t>Ahmmed et al. 2016, fully bendable motion</a:t>
             </a:r>
           </a:p>
         </p:txBody>
@@ -5419,7 +5767,7 @@
                 </a:solidFill>
                 <a:latin typeface="Helvetica"/>
               </a:rPr>
-              <a:t>the saving came from cropping; dropped in 2011.</a:t>
+              <a:t>small gain, and only on round wide-angle footage.</a:t>
             </a:r>
           </a:p>
         </p:txBody>
@@ -5458,7 +5806,7 @@
                 </a:solidFill>
                 <a:latin typeface="Helvetica"/>
               </a:rPr>
-              <a:t>Solar Orbiter Metis camera (2020)</a:t>
+              <a:t>Schwarz &amp; Behnke 2025, telepresence</a:t>
             </a:r>
           </a:p>
         </p:txBody>
@@ -5497,7 +5845,46 @@
                 </a:solidFill>
                 <a:latin typeface="Helvetica"/>
               </a:rPr>
-              <a:t>works because the Sun's corona is ring-shaped; a face is not.</a:t>
+              <a:t>a quality map in a stock codec beat warping the pixels.</a:t>
+            </a:r>
+          </a:p>
+        </p:txBody>
+      </p:sp>
+      <p:sp>
+        <p:nvSpPr>
+          <p:cNvPr id="10" name="TextBox 9"/>
+          <p:cNvSpPr txBox="1"/>
+          <p:nvPr/>
+        </p:nvSpPr>
+        <p:spPr>
+          <a:xfrm>
+            <a:off x="548640" y="4709160"/>
+            <a:ext cx="11094415" cy="548640"/>
+          </a:xfrm>
+          <a:prstGeom prst="rect">
+            <a:avLst/>
+          </a:prstGeom>
+          <a:noFill/>
+        </p:spPr>
+        <p:txBody>
+          <a:bodyPr wrap="square" anchor="t" lIns="45720" rIns="45720">
+            <a:spAutoFit/>
+          </a:bodyPr>
+          <a:lstStyle/>
+          <a:p>
+            <a:pPr algn="l">
+              <a:spcAft>
+                <a:spcPts val="800"/>
+              </a:spcAft>
+            </a:pPr>
+            <a:r>
+              <a:rPr sz="2000" b="1">
+                <a:solidFill>
+                  <a:srgbClr val="F5A623"/>
+                </a:solidFill>
+                <a:latin typeface="Helvetica"/>
+              </a:rPr>
+              <a:t>Six sources, none beat the square grid.</a:t>
             </a:r>
           </a:p>
         </p:txBody>
@@ -5562,7 +5949,7 @@
                 </a:solidFill>
                 <a:latin typeface="Helvetica"/>
               </a:rPr>
-              <a:t>What others tried: polar for still images (2 of 2)</a:t>
+              <a:t>What others tried: polar for still images (1 of 2)</a:t>
             </a:r>
           </a:p>
         </p:txBody>
@@ -5640,7 +6027,7 @@
                 </a:solidFill>
                 <a:latin typeface="Helvetica"/>
               </a:rPr>
-              <a:t>JPEG 2000 region of interest (Christopoulos 2000)</a:t>
+              <a:t>Log-polar retina sensors (Sandini, Berton 2006)</a:t>
             </a:r>
           </a:p>
         </p:txBody>
@@ -5679,7 +6066,7 @@
                 </a:solidFill>
                 <a:latin typeface="Helvetica"/>
               </a:rPr>
-              <a:t>mark the disc as important on the square: nearly free.</a:t>
+              <a:t>fewer pixels toward the rim; never became a product.</a:t>
             </a:r>
           </a:p>
         </p:txBody>
@@ -5718,7 +6105,7 @@
                 </a:solidFill>
                 <a:latin typeface="Helvetica"/>
               </a:rPr>
-              <a:t>Foveated wavelet coding (Wang &amp; Bovik 2001)</a:t>
+              <a:t>Iris rubber-sheet format, ISO 19794-6 (2005)</a:t>
             </a:r>
           </a:p>
         </p:txBody>
@@ -5757,7 +6144,7 @@
                 </a:solidFill>
                 <a:latin typeface="Helvetica"/>
               </a:rPr>
-              <a:t>centre weighting pays only at extreme compression.</a:t>
+              <a:t>the saving came from cropping; dropped in 2011.</a:t>
             </a:r>
           </a:p>
         </p:txBody>
@@ -5796,7 +6183,7 @@
                 </a:solidFill>
                 <a:latin typeface="Helvetica"/>
               </a:rPr>
-              <a:t>Polar iris statistics (Uhl group 2009)</a:t>
+              <a:t>Solar Orbiter Metis camera (2020)</a:t>
             </a:r>
           </a:p>
         </p:txBody>
@@ -5835,46 +6222,7 @@
                 </a:solidFill>
                 <a:latin typeface="Helvetica"/>
               </a:rPr>
-              <a:t>polar pictures stretch differently along and across rings; stock codec tables fit badly.</a:t>
-            </a:r>
-          </a:p>
-        </p:txBody>
-      </p:sp>
-      <p:sp>
-        <p:nvSpPr>
-          <p:cNvPr id="10" name="TextBox 9"/>
-          <p:cNvSpPr txBox="1"/>
-          <p:nvPr/>
-        </p:nvSpPr>
-        <p:spPr>
-          <a:xfrm>
-            <a:off x="548640" y="4709160"/>
-            <a:ext cx="11094415" cy="548640"/>
-          </a:xfrm>
-          <a:prstGeom prst="rect">
-            <a:avLst/>
-          </a:prstGeom>
-          <a:noFill/>
-        </p:spPr>
-        <p:txBody>
-          <a:bodyPr wrap="square" anchor="t" lIns="45720" rIns="45720">
-            <a:spAutoFit/>
-          </a:bodyPr>
-          <a:lstStyle/>
-          <a:p>
-            <a:pPr algn="l">
-              <a:spcAft>
-                <a:spcPts val="800"/>
-              </a:spcAft>
-            </a:pPr>
-            <a:r>
-              <a:rPr sz="2000" b="1">
-                <a:solidFill>
-                  <a:srgbClr val="F5A623"/>
-                </a:solidFill>
-                <a:latin typeface="Helvetica"/>
-              </a:rPr>
-              <a:t>Six sources, none beat the square grid.</a:t>
+              <a:t>works because the Sun's corona is ring-shaped; a face is not.</a:t>
             </a:r>
           </a:p>
         </p:txBody>
@@ -5939,7 +6287,7 @@
                 </a:solidFill>
                 <a:latin typeface="Helvetica"/>
               </a:rPr>
-              <a:t>Should we build a polar still-image coder first?</a:t>
+              <a:t>What others tried: polar for still images (2 of 2)</a:t>
             </a:r>
           </a:p>
         </p:txBody>
@@ -5952,8 +6300,8 @@
         </p:nvSpPr>
         <p:spPr>
           <a:xfrm>
-            <a:off x="548640" y="1371600"/>
-            <a:ext cx="11094415" cy="640080"/>
+            <a:off x="548640" y="6263640"/>
+            <a:ext cx="11094415" cy="457200"/>
           </a:xfrm>
           <a:prstGeom prst="rect">
             <a:avLst/>
@@ -5972,70 +6320,27 @@
               </a:spcAft>
             </a:pPr>
             <a:r>
-              <a:rPr sz="1800" b="0">
+              <a:rPr sz="1100" b="0">
                 <a:solidFill>
                   <a:srgbClr val="9AA7B4"/>
                 </a:solidFill>
                 <a:latin typeface="Helvetica"/>
               </a:rPr>
-              <a:t>Still-only test = the same pipeline with motion prediction switched off.</a:t>
-            </a:r>
-          </a:p>
-        </p:txBody>
-      </p:sp>
-      <p:sp>
-        <p:nvSpPr>
-          <p:cNvPr id="4" name="Rounded Rectangle 3"/>
-          <p:cNvSpPr/>
-          <p:nvPr/>
-        </p:nvSpPr>
-        <p:spPr>
-          <a:xfrm>
-            <a:off x="548640" y="2103120"/>
-            <a:ext cx="5394960" cy="2377440"/>
-          </a:xfrm>
-          <a:prstGeom prst="roundRect">
-            <a:avLst/>
-          </a:prstGeom>
-          <a:solidFill>
-            <a:srgbClr val="151D27"/>
-          </a:solidFill>
-          <a:ln>
-            <a:noFill/>
-          </a:ln>
-        </p:spPr>
-        <p:style>
-          <a:lnRef idx="1">
-            <a:schemeClr val="accent1"/>
-          </a:lnRef>
-          <a:fillRef idx="3">
-            <a:schemeClr val="accent1"/>
-          </a:fillRef>
-          <a:effectRef idx="2">
-            <a:schemeClr val="accent1"/>
-          </a:effectRef>
-          <a:fontRef idx="minor">
-            <a:schemeClr val="lt1"/>
-          </a:fontRef>
-        </p:style>
-        <p:txBody>
-          <a:bodyPr rtlCol="0" anchor="ctr"/>
-          <a:lstStyle/>
-          <a:p>
-            <a:pPr algn="ctr"/>
-          </a:p>
-        </p:txBody>
-      </p:sp>
-      <p:sp>
-        <p:nvSpPr>
-          <p:cNvPr id="5" name="TextBox 4"/>
+              <a:t>Numbers and links: docs/research/polar-coding-literature.md, lens 2.</a:t>
+            </a:r>
+          </a:p>
+        </p:txBody>
+      </p:sp>
+      <p:sp>
+        <p:nvSpPr>
+          <p:cNvPr id="4" name="TextBox 3"/>
           <p:cNvSpPr txBox="1"/>
           <p:nvPr/>
         </p:nvSpPr>
         <p:spPr>
           <a:xfrm>
-            <a:off x="731520" y="2240280"/>
-            <a:ext cx="5029200" cy="548640"/>
+            <a:off x="548640" y="1371600"/>
+            <a:ext cx="4206240" cy="914400"/>
           </a:xfrm>
           <a:prstGeom prst="rect">
             <a:avLst/>
@@ -6054,27 +6359,27 @@
               </a:spcAft>
             </a:pPr>
             <a:r>
-              <a:rPr sz="2000" b="1">
+              <a:rPr sz="2000" b="0">
                 <a:solidFill>
                   <a:srgbClr val="4CC2FF"/>
                 </a:solidFill>
                 <a:latin typeface="Helvetica"/>
               </a:rPr>
-              <a:t>it would show</a:t>
-            </a:r>
-          </a:p>
-        </p:txBody>
-      </p:sp>
-      <p:sp>
-        <p:nvSpPr>
-          <p:cNvPr id="6" name="TextBox 5"/>
+              <a:t>JPEG 2000 region of interest (Christopoulos 2000)</a:t>
+            </a:r>
+          </a:p>
+        </p:txBody>
+      </p:sp>
+      <p:sp>
+        <p:nvSpPr>
+          <p:cNvPr id="5" name="TextBox 4"/>
           <p:cNvSpPr txBox="1"/>
           <p:nvPr/>
         </p:nvSpPr>
         <p:spPr>
           <a:xfrm>
-            <a:off x="731520" y="2834640"/>
-            <a:ext cx="5029200" cy="2011680"/>
+            <a:off x="4846320" y="1371600"/>
+            <a:ext cx="6796735" cy="914400"/>
           </a:xfrm>
           <a:prstGeom prst="rect">
             <a:avLst/>
@@ -6093,86 +6398,27 @@
               </a:spcAft>
             </a:pPr>
             <a:r>
-              <a:rPr sz="1700" b="0">
+              <a:rPr sz="2000" b="0">
                 <a:solidFill>
                   <a:srgbClr val="E6EDF3"/>
                 </a:solidFill>
                 <a:latin typeface="Helvetica"/>
               </a:rPr>
-              <a:t>• the share of the +82 % that is pure resampling</a:t>
-            </a:r>
-          </a:p>
-          <a:p>
-            <a:pPr algn="l">
-              <a:spcAft>
-                <a:spcPts val="800"/>
-              </a:spcAft>
-            </a:pPr>
-            <a:r>
-              <a:rPr sz="1700" b="0">
-                <a:solidFill>
-                  <a:srgbClr val="E6EDF3"/>
-                </a:solidFill>
-                <a:latin typeface="Helvetica"/>
-              </a:rPr>
-              <a:t>• how much depends on where the centre sits</a:t>
-            </a:r>
-          </a:p>
-        </p:txBody>
-      </p:sp>
-      <p:sp>
-        <p:nvSpPr>
-          <p:cNvPr id="7" name="Rounded Rectangle 6"/>
-          <p:cNvSpPr/>
-          <p:nvPr/>
-        </p:nvSpPr>
-        <p:spPr>
-          <a:xfrm>
-            <a:off x="6217920" y="2103120"/>
-            <a:ext cx="5394960" cy="2377440"/>
-          </a:xfrm>
-          <a:prstGeom prst="roundRect">
-            <a:avLst/>
-          </a:prstGeom>
-          <a:solidFill>
-            <a:srgbClr val="151D27"/>
-          </a:solidFill>
-          <a:ln>
-            <a:noFill/>
-          </a:ln>
-        </p:spPr>
-        <p:style>
-          <a:lnRef idx="1">
-            <a:schemeClr val="accent1"/>
-          </a:lnRef>
-          <a:fillRef idx="3">
-            <a:schemeClr val="accent1"/>
-          </a:fillRef>
-          <a:effectRef idx="2">
-            <a:schemeClr val="accent1"/>
-          </a:effectRef>
-          <a:fontRef idx="minor">
-            <a:schemeClr val="lt1"/>
-          </a:fontRef>
-        </p:style>
-        <p:txBody>
-          <a:bodyPr rtlCol="0" anchor="ctr"/>
-          <a:lstStyle/>
-          <a:p>
-            <a:pPr algn="ctr"/>
-          </a:p>
-        </p:txBody>
-      </p:sp>
-      <p:sp>
-        <p:nvSpPr>
-          <p:cNvPr id="8" name="TextBox 7"/>
+              <a:t>mark the disc as important on the square: nearly free.</a:t>
+            </a:r>
+          </a:p>
+        </p:txBody>
+      </p:sp>
+      <p:sp>
+        <p:nvSpPr>
+          <p:cNvPr id="6" name="TextBox 5"/>
           <p:cNvSpPr txBox="1"/>
           <p:nvPr/>
         </p:nvSpPr>
         <p:spPr>
           <a:xfrm>
-            <a:off x="6400800" y="2240280"/>
-            <a:ext cx="5029200" cy="548640"/>
+            <a:off x="548640" y="2423160"/>
+            <a:ext cx="4206240" cy="914400"/>
           </a:xfrm>
           <a:prstGeom prst="rect">
             <a:avLst/>
@@ -6191,27 +6437,27 @@
               </a:spcAft>
             </a:pPr>
             <a:r>
-              <a:rPr sz="2000" b="1">
+              <a:rPr sz="2000" b="0">
                 <a:solidFill>
                   <a:srgbClr val="4CC2FF"/>
                 </a:solidFill>
                 <a:latin typeface="Helvetica"/>
               </a:rPr>
-              <a:t>it cannot show</a:t>
-            </a:r>
-          </a:p>
-        </p:txBody>
-      </p:sp>
-      <p:sp>
-        <p:nvSpPr>
-          <p:cNvPr id="9" name="TextBox 8"/>
+              <a:t>Foveated wavelet coding (Wang &amp; Bovik 2001)</a:t>
+            </a:r>
+          </a:p>
+        </p:txBody>
+      </p:sp>
+      <p:sp>
+        <p:nvSpPr>
+          <p:cNvPr id="7" name="TextBox 6"/>
           <p:cNvSpPr txBox="1"/>
           <p:nvPr/>
         </p:nvSpPr>
         <p:spPr>
           <a:xfrm>
-            <a:off x="6400800" y="2834640"/>
-            <a:ext cx="5029200" cy="2011680"/>
+            <a:off x="4846320" y="2423160"/>
+            <a:ext cx="6796735" cy="914400"/>
           </a:xfrm>
           <a:prstGeom prst="rect">
             <a:avLst/>
@@ -6230,43 +6476,27 @@
               </a:spcAft>
             </a:pPr>
             <a:r>
-              <a:rPr sz="1700" b="0">
+              <a:rPr sz="2000" b="0">
                 <a:solidFill>
                   <a:srgbClr val="E6EDF3"/>
                 </a:solidFill>
                 <a:latin typeface="Helvetica"/>
               </a:rPr>
-              <a:t>• motion, where most of the bytes go</a:t>
-            </a:r>
-          </a:p>
-          <a:p>
-            <a:pPr algn="l">
-              <a:spcAft>
-                <a:spcPts val="800"/>
-              </a:spcAft>
-            </a:pPr>
-            <a:r>
-              <a:rPr sz="1700" b="0">
-                <a:solidFill>
-                  <a:srgbClr val="E6EDF3"/>
-                </a:solidFill>
-                <a:latin typeface="Helvetica"/>
-              </a:rPr>
-              <a:t>• still tests exaggerate geometry effects</a:t>
-            </a:r>
-          </a:p>
-        </p:txBody>
-      </p:sp>
-      <p:sp>
-        <p:nvSpPr>
-          <p:cNvPr id="10" name="TextBox 9"/>
+              <a:t>centre weighting pays only at extreme compression.</a:t>
+            </a:r>
+          </a:p>
+        </p:txBody>
+      </p:sp>
+      <p:sp>
+        <p:nvSpPr>
+          <p:cNvPr id="8" name="TextBox 7"/>
           <p:cNvSpPr txBox="1"/>
           <p:nvPr/>
         </p:nvSpPr>
         <p:spPr>
           <a:xfrm>
-            <a:off x="548640" y="4572000"/>
-            <a:ext cx="11094415" cy="1371600"/>
+            <a:off x="548640" y="3474720"/>
+            <a:ext cx="4206240" cy="914400"/>
           </a:xfrm>
           <a:prstGeom prst="rect">
             <a:avLst/>
@@ -6285,13 +6515,91 @@
               </a:spcAft>
             </a:pPr>
             <a:r>
-              <a:rPr sz="1800" b="0">
+              <a:rPr sz="2000" b="0">
+                <a:solidFill>
+                  <a:srgbClr val="4CC2FF"/>
+                </a:solidFill>
+                <a:latin typeface="Helvetica"/>
+              </a:rPr>
+              <a:t>Polar iris statistics (Uhl group 2009)</a:t>
+            </a:r>
+          </a:p>
+        </p:txBody>
+      </p:sp>
+      <p:sp>
+        <p:nvSpPr>
+          <p:cNvPr id="9" name="TextBox 8"/>
+          <p:cNvSpPr txBox="1"/>
+          <p:nvPr/>
+        </p:nvSpPr>
+        <p:spPr>
+          <a:xfrm>
+            <a:off x="4846320" y="3474720"/>
+            <a:ext cx="6796735" cy="914400"/>
+          </a:xfrm>
+          <a:prstGeom prst="rect">
+            <a:avLst/>
+          </a:prstGeom>
+          <a:noFill/>
+        </p:spPr>
+        <p:txBody>
+          <a:bodyPr wrap="square" anchor="t" lIns="45720" rIns="45720">
+            <a:spAutoFit/>
+          </a:bodyPr>
+          <a:lstStyle/>
+          <a:p>
+            <a:pPr algn="l">
+              <a:spcAft>
+                <a:spcPts val="800"/>
+              </a:spcAft>
+            </a:pPr>
+            <a:r>
+              <a:rPr sz="2000" b="0">
+                <a:solidFill>
+                  <a:srgbClr val="E6EDF3"/>
+                </a:solidFill>
+                <a:latin typeface="Helvetica"/>
+              </a:rPr>
+              <a:t>polar pictures stretch differently along and across rings; stock codec tables fit badly.</a:t>
+            </a:r>
+          </a:p>
+        </p:txBody>
+      </p:sp>
+      <p:sp>
+        <p:nvSpPr>
+          <p:cNvPr id="10" name="TextBox 9"/>
+          <p:cNvSpPr txBox="1"/>
+          <p:nvPr/>
+        </p:nvSpPr>
+        <p:spPr>
+          <a:xfrm>
+            <a:off x="548640" y="4709160"/>
+            <a:ext cx="11094415" cy="548640"/>
+          </a:xfrm>
+          <a:prstGeom prst="rect">
+            <a:avLst/>
+          </a:prstGeom>
+          <a:noFill/>
+        </p:spPr>
+        <p:txBody>
+          <a:bodyPr wrap="square" anchor="t" lIns="45720" rIns="45720">
+            <a:spAutoFit/>
+          </a:bodyPr>
+          <a:lstStyle/>
+          <a:p>
+            <a:pPr algn="l">
+              <a:spcAft>
+                <a:spcPts val="800"/>
+              </a:spcAft>
+            </a:pPr>
+            <a:r>
+              <a:rPr sz="2000" b="1">
                 <a:solidFill>
                   <a:srgbClr val="F5A623"/>
                 </a:solidFill>
                 <a:latin typeface="Helvetica"/>
               </a:rPr>
-              <a:t>Verdict: no new coder; switch off motion prediction in the existing pipeline instead.</a:t>
+              <a:t>Six sources, none beat the square grid.</a:t>
             </a:r>
           </a:p>
         </p:txBody>
@@ -6657,21 +6965,60 @@
                 </a:solidFill>
                 <a:latin typeface="Helvetica"/>
               </a:rPr>
-              <a:t>Three ways to use polar maths from here</a:t>
-            </a:r>
-          </a:p>
-        </p:txBody>
-      </p:sp>
-      <p:sp>
-        <p:nvSpPr>
-          <p:cNvPr id="3" name="Rounded Rectangle 2"/>
+              <a:t>Should we build a polar still-image coder first?</a:t>
+            </a:r>
+          </a:p>
+        </p:txBody>
+      </p:sp>
+      <p:sp>
+        <p:nvSpPr>
+          <p:cNvPr id="3" name="TextBox 2"/>
+          <p:cNvSpPr txBox="1"/>
+          <p:nvPr/>
+        </p:nvSpPr>
+        <p:spPr>
+          <a:xfrm>
+            <a:off x="548640" y="1371600"/>
+            <a:ext cx="11094415" cy="640080"/>
+          </a:xfrm>
+          <a:prstGeom prst="rect">
+            <a:avLst/>
+          </a:prstGeom>
+          <a:noFill/>
+        </p:spPr>
+        <p:txBody>
+          <a:bodyPr wrap="square" anchor="t" lIns="45720" rIns="45720">
+            <a:spAutoFit/>
+          </a:bodyPr>
+          <a:lstStyle/>
+          <a:p>
+            <a:pPr algn="l">
+              <a:spcAft>
+                <a:spcPts val="800"/>
+              </a:spcAft>
+            </a:pPr>
+            <a:r>
+              <a:rPr sz="1800" b="0">
+                <a:solidFill>
+                  <a:srgbClr val="9AA7B4"/>
+                </a:solidFill>
+                <a:latin typeface="Helvetica"/>
+              </a:rPr>
+              <a:t>Still-only test = the same pipeline with motion prediction switched off.</a:t>
+            </a:r>
+          </a:p>
+        </p:txBody>
+      </p:sp>
+      <p:sp>
+        <p:nvSpPr>
+          <p:cNvPr id="4" name="Rounded Rectangle 3"/>
           <p:cNvSpPr/>
           <p:nvPr/>
         </p:nvSpPr>
         <p:spPr>
           <a:xfrm>
-            <a:off x="548640" y="1371600"/>
-            <a:ext cx="3566160" cy="2926080"/>
+            <a:off x="548640" y="2103120"/>
+            <a:ext cx="5394960" cy="2377440"/>
           </a:xfrm>
           <a:prstGeom prst="roundRect">
             <a:avLst/>
@@ -6679,10 +7026,8 @@
           <a:solidFill>
             <a:srgbClr val="151D27"/>
           </a:solidFill>
-          <a:ln w="38100">
-            <a:solidFill>
-              <a:srgbClr val="FF6B6B"/>
-            </a:solidFill>
+          <a:ln>
+            <a:noFill/>
           </a:ln>
         </p:spPr>
         <p:style>
@@ -6709,14 +7054,14 @@
       </p:sp>
       <p:sp>
         <p:nvSpPr>
-          <p:cNvPr id="4" name="TextBox 3"/>
+          <p:cNvPr id="5" name="TextBox 4"/>
           <p:cNvSpPr txBox="1"/>
           <p:nvPr/>
         </p:nvSpPr>
         <p:spPr>
           <a:xfrm>
-            <a:off x="731520" y="1508760"/>
-            <a:ext cx="3200400" cy="822960"/>
+            <a:off x="731520" y="2240280"/>
+            <a:ext cx="5029200" cy="548640"/>
           </a:xfrm>
           <a:prstGeom prst="rect">
             <a:avLst/>
@@ -6735,27 +7080,27 @@
               </a:spcAft>
             </a:pPr>
             <a:r>
-              <a:rPr sz="1800" b="1">
-                <a:solidFill>
-                  <a:srgbClr val="FF6B6B"/>
-                </a:solidFill>
-                <a:latin typeface="Helvetica"/>
-              </a:rPr>
-              <a:t>1. Polar as the stored picture</a:t>
-            </a:r>
-          </a:p>
-        </p:txBody>
-      </p:sp>
-      <p:sp>
-        <p:nvSpPr>
-          <p:cNvPr id="5" name="TextBox 4"/>
+              <a:rPr sz="2000" b="1">
+                <a:solidFill>
+                  <a:srgbClr val="4CC2FF"/>
+                </a:solidFill>
+                <a:latin typeface="Helvetica"/>
+              </a:rPr>
+              <a:t>it would show</a:t>
+            </a:r>
+          </a:p>
+        </p:txBody>
+      </p:sp>
+      <p:sp>
+        <p:nvSpPr>
+          <p:cNvPr id="6" name="TextBox 5"/>
           <p:cNvSpPr txBox="1"/>
           <p:nvPr/>
         </p:nvSpPr>
         <p:spPr>
           <a:xfrm>
-            <a:off x="731520" y="2377440"/>
-            <a:ext cx="3200400" cy="1828800"/>
+            <a:off x="731520" y="2834640"/>
+            <a:ext cx="5029200" cy="2011680"/>
           </a:xfrm>
           <a:prstGeom prst="rect">
             <a:avLst/>
@@ -6774,27 +7119,43 @@
               </a:spcAft>
             </a:pPr>
             <a:r>
-              <a:rPr sz="1600" b="0">
+              <a:rPr sz="1700" b="0">
                 <a:solidFill>
                   <a:srgbClr val="E6EDF3"/>
                 </a:solidFill>
                 <a:latin typeface="Helvetica"/>
               </a:rPr>
-              <a:t>1.82x the bytes. Closed.</a:t>
-            </a:r>
-          </a:p>
-        </p:txBody>
-      </p:sp>
-      <p:sp>
-        <p:nvSpPr>
-          <p:cNvPr id="6" name="Rounded Rectangle 5"/>
+              <a:t>• the share of the +82 % that is pure resampling</a:t>
+            </a:r>
+          </a:p>
+          <a:p>
+            <a:pPr algn="l">
+              <a:spcAft>
+                <a:spcPts val="800"/>
+              </a:spcAft>
+            </a:pPr>
+            <a:r>
+              <a:rPr sz="1700" b="0">
+                <a:solidFill>
+                  <a:srgbClr val="E6EDF3"/>
+                </a:solidFill>
+                <a:latin typeface="Helvetica"/>
+              </a:rPr>
+              <a:t>• how much depends on where the centre sits</a:t>
+            </a:r>
+          </a:p>
+        </p:txBody>
+      </p:sp>
+      <p:sp>
+        <p:nvSpPr>
+          <p:cNvPr id="7" name="Rounded Rectangle 6"/>
           <p:cNvSpPr/>
           <p:nvPr/>
         </p:nvSpPr>
         <p:spPr>
           <a:xfrm>
-            <a:off x="4297679" y="1371600"/>
-            <a:ext cx="3566160" cy="2926080"/>
+            <a:off x="6217920" y="2103120"/>
+            <a:ext cx="5394960" cy="2377440"/>
           </a:xfrm>
           <a:prstGeom prst="roundRect">
             <a:avLst/>
@@ -6802,10 +7163,8 @@
           <a:solidFill>
             <a:srgbClr val="151D27"/>
           </a:solidFill>
-          <a:ln w="38100">
-            <a:solidFill>
-              <a:srgbClr val="F5A623"/>
-            </a:solidFill>
+          <a:ln>
+            <a:noFill/>
           </a:ln>
         </p:spPr>
         <p:style>
@@ -6832,14 +7191,14 @@
       </p:sp>
       <p:sp>
         <p:nvSpPr>
-          <p:cNvPr id="7" name="TextBox 6"/>
+          <p:cNvPr id="8" name="TextBox 7"/>
           <p:cNvSpPr txBox="1"/>
           <p:nvPr/>
         </p:nvSpPr>
         <p:spPr>
           <a:xfrm>
-            <a:off x="4480559" y="1508760"/>
-            <a:ext cx="3200400" cy="822960"/>
+            <a:off x="6400800" y="2240280"/>
+            <a:ext cx="5029200" cy="548640"/>
           </a:xfrm>
           <a:prstGeom prst="rect">
             <a:avLst/>
@@ -6858,27 +7217,27 @@
               </a:spcAft>
             </a:pPr>
             <a:r>
-              <a:rPr sz="1800" b="1">
-                <a:solidFill>
-                  <a:srgbClr val="F5A623"/>
-                </a:solidFill>
-                <a:latin typeface="Helvetica"/>
-              </a:rPr>
-              <a:t>2. Polar motion inside a codec</a:t>
-            </a:r>
-          </a:p>
-        </p:txBody>
-      </p:sp>
-      <p:sp>
-        <p:nvSpPr>
-          <p:cNvPr id="8" name="TextBox 7"/>
+              <a:rPr sz="2000" b="1">
+                <a:solidFill>
+                  <a:srgbClr val="4CC2FF"/>
+                </a:solidFill>
+                <a:latin typeface="Helvetica"/>
+              </a:rPr>
+              <a:t>it cannot show</a:t>
+            </a:r>
+          </a:p>
+        </p:txBody>
+      </p:sp>
+      <p:sp>
+        <p:nvSpPr>
+          <p:cNvPr id="9" name="TextBox 8"/>
           <p:cNvSpPr txBox="1"/>
           <p:nvPr/>
         </p:nvSpPr>
         <p:spPr>
           <a:xfrm>
-            <a:off x="4480559" y="2377440"/>
-            <a:ext cx="3200400" cy="1828800"/>
+            <a:off x="6400800" y="2834640"/>
+            <a:ext cx="5029200" cy="2011680"/>
           </a:xfrm>
           <a:prstGeom prst="rect">
             <a:avLst/>
@@ -6897,26 +7256,146 @@
               </a:spcAft>
             </a:pPr>
             <a:r>
-              <a:rPr sz="1600" b="0">
+              <a:rPr sz="1700" b="0">
                 <a:solidFill>
                   <a:srgbClr val="E6EDF3"/>
                 </a:solidFill>
                 <a:latin typeface="Helvetica"/>
               </a:rPr>
-              <a:t>Measured: AV1's own turn-and-zoom tools leave polar a 21 % edge on a fast spin only, and real circles do not spin. Not worth building.</a:t>
-            </a:r>
-          </a:p>
-        </p:txBody>
-      </p:sp>
-      <p:sp>
-        <p:nvSpPr>
-          <p:cNvPr id="9" name="Rounded Rectangle 8"/>
+              <a:t>• motion, where most of the bytes go</a:t>
+            </a:r>
+          </a:p>
+          <a:p>
+            <a:pPr algn="l">
+              <a:spcAft>
+                <a:spcPts val="800"/>
+              </a:spcAft>
+            </a:pPr>
+            <a:r>
+              <a:rPr sz="1700" b="0">
+                <a:solidFill>
+                  <a:srgbClr val="E6EDF3"/>
+                </a:solidFill>
+                <a:latin typeface="Helvetica"/>
+              </a:rPr>
+              <a:t>• still tests exaggerate geometry effects</a:t>
+            </a:r>
+          </a:p>
+        </p:txBody>
+      </p:sp>
+      <p:sp>
+        <p:nvSpPr>
+          <p:cNvPr id="10" name="TextBox 9"/>
+          <p:cNvSpPr txBox="1"/>
+          <p:nvPr/>
+        </p:nvSpPr>
+        <p:spPr>
+          <a:xfrm>
+            <a:off x="548640" y="4572000"/>
+            <a:ext cx="11094415" cy="1371600"/>
+          </a:xfrm>
+          <a:prstGeom prst="rect">
+            <a:avLst/>
+          </a:prstGeom>
+          <a:noFill/>
+        </p:spPr>
+        <p:txBody>
+          <a:bodyPr wrap="square" anchor="t" lIns="45720" rIns="45720">
+            <a:spAutoFit/>
+          </a:bodyPr>
+          <a:lstStyle/>
+          <a:p>
+            <a:pPr algn="l">
+              <a:spcAft>
+                <a:spcPts val="800"/>
+              </a:spcAft>
+            </a:pPr>
+            <a:r>
+              <a:rPr sz="1800" b="0">
+                <a:solidFill>
+                  <a:srgbClr val="F5A623"/>
+                </a:solidFill>
+                <a:latin typeface="Helvetica"/>
+              </a:rPr>
+              <a:t>Verdict: no new coder; switch off motion prediction in the existing pipeline instead.</a:t>
+            </a:r>
+          </a:p>
+        </p:txBody>
+      </p:sp>
+    </p:spTree>
+  </p:cSld>
+  <p:clrMapOvr>
+    <a:masterClrMapping/>
+  </p:clrMapOvr>
+</p:sld>
+</file>
+
+<file path=ppt/slides/slide21.xml><?xml version="1.0" encoding="utf-8"?>
+<p:sld xmlns:a="http://schemas.openxmlformats.org/drawingml/2006/main" xmlns:p="http://schemas.openxmlformats.org/presentationml/2006/main" xmlns:r="http://schemas.openxmlformats.org/officeDocument/2006/relationships">
+  <p:cSld>
+    <p:bg>
+      <p:bgPr>
+        <a:solidFill>
+          <a:srgbClr val="0B1016"/>
+        </a:solidFill>
+        <a:effectLst/>
+      </p:bgPr>
+    </p:bg>
+    <p:spTree>
+      <p:nvGrpSpPr>
+        <p:cNvPr id="1" name=""/>
+        <p:cNvGrpSpPr/>
+        <p:nvPr/>
+      </p:nvGrpSpPr>
+      <p:grpSpPr/>
+      <p:sp>
+        <p:nvSpPr>
+          <p:cNvPr id="2" name="TextBox 1"/>
+          <p:cNvSpPr txBox="1"/>
+          <p:nvPr/>
+        </p:nvSpPr>
+        <p:spPr>
+          <a:xfrm>
+            <a:off x="548640" y="320040"/>
+            <a:ext cx="11094415" cy="914400"/>
+          </a:xfrm>
+          <a:prstGeom prst="rect">
+            <a:avLst/>
+          </a:prstGeom>
+          <a:noFill/>
+        </p:spPr>
+        <p:txBody>
+          <a:bodyPr wrap="square" anchor="t" lIns="45720" rIns="45720">
+            <a:spAutoFit/>
+          </a:bodyPr>
+          <a:lstStyle/>
+          <a:p>
+            <a:pPr algn="l">
+              <a:spcAft>
+                <a:spcPts val="800"/>
+              </a:spcAft>
+            </a:pPr>
+            <a:r>
+              <a:rPr sz="3400" b="1">
+                <a:solidFill>
+                  <a:srgbClr val="E6EDF3"/>
+                </a:solidFill>
+                <a:latin typeface="Helvetica"/>
+              </a:rPr>
+              <a:t>Three ways to use polar maths from here</a:t>
+            </a:r>
+          </a:p>
+        </p:txBody>
+      </p:sp>
+      <p:sp>
+        <p:nvSpPr>
+          <p:cNvPr id="3" name="Rounded Rectangle 2"/>
           <p:cNvSpPr/>
           <p:nvPr/>
         </p:nvSpPr>
         <p:spPr>
           <a:xfrm>
-            <a:off x="8046718" y="1371600"/>
+            <a:off x="548640" y="1371600"/>
             <a:ext cx="3566160" cy="2926080"/>
           </a:xfrm>
           <a:prstGeom prst="roundRect">
@@ -6927,7 +7406,7 @@
           </a:solidFill>
           <a:ln w="38100">
             <a:solidFill>
-              <a:srgbClr val="6FD36F"/>
+              <a:srgbClr val="FF6B6B"/>
             </a:solidFill>
           </a:ln>
         </p:spPr>
@@ -6955,6 +7434,252 @@
       </p:sp>
       <p:sp>
         <p:nvSpPr>
+          <p:cNvPr id="4" name="TextBox 3"/>
+          <p:cNvSpPr txBox="1"/>
+          <p:nvPr/>
+        </p:nvSpPr>
+        <p:spPr>
+          <a:xfrm>
+            <a:off x="731520" y="1508760"/>
+            <a:ext cx="3200400" cy="822960"/>
+          </a:xfrm>
+          <a:prstGeom prst="rect">
+            <a:avLst/>
+          </a:prstGeom>
+          <a:noFill/>
+        </p:spPr>
+        <p:txBody>
+          <a:bodyPr wrap="square" anchor="t" lIns="45720" rIns="45720">
+            <a:spAutoFit/>
+          </a:bodyPr>
+          <a:lstStyle/>
+          <a:p>
+            <a:pPr algn="l">
+              <a:spcAft>
+                <a:spcPts val="800"/>
+              </a:spcAft>
+            </a:pPr>
+            <a:r>
+              <a:rPr sz="1800" b="1">
+                <a:solidFill>
+                  <a:srgbClr val="FF6B6B"/>
+                </a:solidFill>
+                <a:latin typeface="Helvetica"/>
+              </a:rPr>
+              <a:t>1. Polar as the stored picture</a:t>
+            </a:r>
+          </a:p>
+        </p:txBody>
+      </p:sp>
+      <p:sp>
+        <p:nvSpPr>
+          <p:cNvPr id="5" name="TextBox 4"/>
+          <p:cNvSpPr txBox="1"/>
+          <p:nvPr/>
+        </p:nvSpPr>
+        <p:spPr>
+          <a:xfrm>
+            <a:off x="731520" y="2377440"/>
+            <a:ext cx="3200400" cy="1828800"/>
+          </a:xfrm>
+          <a:prstGeom prst="rect">
+            <a:avLst/>
+          </a:prstGeom>
+          <a:noFill/>
+        </p:spPr>
+        <p:txBody>
+          <a:bodyPr wrap="square" anchor="t" lIns="45720" rIns="45720">
+            <a:spAutoFit/>
+          </a:bodyPr>
+          <a:lstStyle/>
+          <a:p>
+            <a:pPr algn="l">
+              <a:spcAft>
+                <a:spcPts val="800"/>
+              </a:spcAft>
+            </a:pPr>
+            <a:r>
+              <a:rPr sz="1600" b="0">
+                <a:solidFill>
+                  <a:srgbClr val="E6EDF3"/>
+                </a:solidFill>
+                <a:latin typeface="Helvetica"/>
+              </a:rPr>
+              <a:t>1.82x the bytes. Closed.</a:t>
+            </a:r>
+          </a:p>
+        </p:txBody>
+      </p:sp>
+      <p:sp>
+        <p:nvSpPr>
+          <p:cNvPr id="6" name="Rounded Rectangle 5"/>
+          <p:cNvSpPr/>
+          <p:nvPr/>
+        </p:nvSpPr>
+        <p:spPr>
+          <a:xfrm>
+            <a:off x="4297679" y="1371600"/>
+            <a:ext cx="3566160" cy="2926080"/>
+          </a:xfrm>
+          <a:prstGeom prst="roundRect">
+            <a:avLst/>
+          </a:prstGeom>
+          <a:solidFill>
+            <a:srgbClr val="151D27"/>
+          </a:solidFill>
+          <a:ln w="38100">
+            <a:solidFill>
+              <a:srgbClr val="F5A623"/>
+            </a:solidFill>
+          </a:ln>
+        </p:spPr>
+        <p:style>
+          <a:lnRef idx="1">
+            <a:schemeClr val="accent1"/>
+          </a:lnRef>
+          <a:fillRef idx="3">
+            <a:schemeClr val="accent1"/>
+          </a:fillRef>
+          <a:effectRef idx="2">
+            <a:schemeClr val="accent1"/>
+          </a:effectRef>
+          <a:fontRef idx="minor">
+            <a:schemeClr val="lt1"/>
+          </a:fontRef>
+        </p:style>
+        <p:txBody>
+          <a:bodyPr rtlCol="0" anchor="ctr"/>
+          <a:lstStyle/>
+          <a:p>
+            <a:pPr algn="ctr"/>
+          </a:p>
+        </p:txBody>
+      </p:sp>
+      <p:sp>
+        <p:nvSpPr>
+          <p:cNvPr id="7" name="TextBox 6"/>
+          <p:cNvSpPr txBox="1"/>
+          <p:nvPr/>
+        </p:nvSpPr>
+        <p:spPr>
+          <a:xfrm>
+            <a:off x="4480559" y="1508760"/>
+            <a:ext cx="3200400" cy="822960"/>
+          </a:xfrm>
+          <a:prstGeom prst="rect">
+            <a:avLst/>
+          </a:prstGeom>
+          <a:noFill/>
+        </p:spPr>
+        <p:txBody>
+          <a:bodyPr wrap="square" anchor="t" lIns="45720" rIns="45720">
+            <a:spAutoFit/>
+          </a:bodyPr>
+          <a:lstStyle/>
+          <a:p>
+            <a:pPr algn="l">
+              <a:spcAft>
+                <a:spcPts val="800"/>
+              </a:spcAft>
+            </a:pPr>
+            <a:r>
+              <a:rPr sz="1800" b="1">
+                <a:solidFill>
+                  <a:srgbClr val="F5A623"/>
+                </a:solidFill>
+                <a:latin typeface="Helvetica"/>
+              </a:rPr>
+              <a:t>2. Polar motion inside a codec</a:t>
+            </a:r>
+          </a:p>
+        </p:txBody>
+      </p:sp>
+      <p:sp>
+        <p:nvSpPr>
+          <p:cNvPr id="8" name="TextBox 7"/>
+          <p:cNvSpPr txBox="1"/>
+          <p:nvPr/>
+        </p:nvSpPr>
+        <p:spPr>
+          <a:xfrm>
+            <a:off x="4480559" y="2377440"/>
+            <a:ext cx="3200400" cy="1828800"/>
+          </a:xfrm>
+          <a:prstGeom prst="rect">
+            <a:avLst/>
+          </a:prstGeom>
+          <a:noFill/>
+        </p:spPr>
+        <p:txBody>
+          <a:bodyPr wrap="square" anchor="t" lIns="45720" rIns="45720">
+            <a:spAutoFit/>
+          </a:bodyPr>
+          <a:lstStyle/>
+          <a:p>
+            <a:pPr algn="l">
+              <a:spcAft>
+                <a:spcPts val="800"/>
+              </a:spcAft>
+            </a:pPr>
+            <a:r>
+              <a:rPr sz="1600" b="0">
+                <a:solidFill>
+                  <a:srgbClr val="E6EDF3"/>
+                </a:solidFill>
+                <a:latin typeface="Helvetica"/>
+              </a:rPr>
+              <a:t>Measured: AV1's own turn-and-zoom tools leave polar a 21 % edge on a fast spin only, and real circles do not spin. Not worth building.</a:t>
+            </a:r>
+          </a:p>
+        </p:txBody>
+      </p:sp>
+      <p:sp>
+        <p:nvSpPr>
+          <p:cNvPr id="9" name="Rounded Rectangle 8"/>
+          <p:cNvSpPr/>
+          <p:nvPr/>
+        </p:nvSpPr>
+        <p:spPr>
+          <a:xfrm>
+            <a:off x="8046718" y="1371600"/>
+            <a:ext cx="3566160" cy="2926080"/>
+          </a:xfrm>
+          <a:prstGeom prst="roundRect">
+            <a:avLst/>
+          </a:prstGeom>
+          <a:solidFill>
+            <a:srgbClr val="151D27"/>
+          </a:solidFill>
+          <a:ln w="38100">
+            <a:solidFill>
+              <a:srgbClr val="6FD36F"/>
+            </a:solidFill>
+          </a:ln>
+        </p:spPr>
+        <p:style>
+          <a:lnRef idx="1">
+            <a:schemeClr val="accent1"/>
+          </a:lnRef>
+          <a:fillRef idx="3">
+            <a:schemeClr val="accent1"/>
+          </a:fillRef>
+          <a:effectRef idx="2">
+            <a:schemeClr val="accent1"/>
+          </a:effectRef>
+          <a:fontRef idx="minor">
+            <a:schemeClr val="lt1"/>
+          </a:fontRef>
+        </p:style>
+        <p:txBody>
+          <a:bodyPr rtlCol="0" anchor="ctr"/>
+          <a:lstStyle/>
+          <a:p>
+            <a:pPr algn="ctr"/>
+          </a:p>
+        </p:txBody>
+      </p:sp>
+      <p:sp>
+        <p:nvSpPr>
           <p:cNvPr id="10" name="TextBox 9"/>
           <p:cNvSpPr txBox="1"/>
           <p:nvPr/>
@@ -7078,7 +7803,7 @@
 </p:sld>
 </file>
 
-<file path=ppt/slides/slide21.xml><?xml version="1.0" encoding="utf-8"?>
+<file path=ppt/slides/slide22.xml><?xml version="1.0" encoding="utf-8"?>
 <p:sld xmlns:a="http://schemas.openxmlformats.org/drawingml/2006/main" xmlns:p="http://schemas.openxmlformats.org/presentationml/2006/main" xmlns:r="http://schemas.openxmlformats.org/officeDocument/2006/relationships">
   <p:cSld>
     <p:bg>
@@ -8667,7 +9392,7 @@
 </p:sld>
 </file>
 
-<file path=ppt/slides/slide22.xml><?xml version="1.0" encoding="utf-8"?>
+<file path=ppt/slides/slide23.xml><?xml version="1.0" encoding="utf-8"?>
 <p:sld xmlns:a="http://schemas.openxmlformats.org/drawingml/2006/main" xmlns:p="http://schemas.openxmlformats.org/presentationml/2006/main" xmlns:r="http://schemas.openxmlformats.org/officeDocument/2006/relationships">
   <p:cSld>
     <p:bg>

</xml_diff>